<commit_message>
docs: MCP-Kapitel auf reale Installation umstellen (aktiv vs. optional) + claude-mem-Nutzung
- §8 getrennte Tabellen: 'bei dir aktiv' (markitdown, context7, claude-mem, context-mode, claude.ai-Connectoren, RTK) vs. 'optional/NICHT installiert' (exa, github→gh-CLI, playwright, memory, sequential-thinking)
- Klarstellung: der 'memory'-MCP (Wissensgraph) ist NICHT installiert/nicht noetig — claude-mem ist die primaere Memory-Quelle
- §10: konkreter claude-mem-Nutzungsblock (Auto-Injektion ab 2. Session, /mem-search, automatische Erfassung)
- PPTX §8 (Aktiv-Tabelle + Optional-Hinweis) und §10-11 entsprechend
- docs/*.docx + *.pptx neu generiert; ecc-doctor unveraendert gruen

Co-Authored-By: Claude Opus 4.8 (1M context) <noreply@anthropic.com>
</commit_message>
<xml_diff>
--- a/docs/ECC-Harness-Guide.de.pptx
+++ b/docs/ECC-Harness-Guide.de.pptx
@@ -4370,8 +4370,8 @@
         </p:nvSpPr>
         <p:spPr>
           <a:xfrm>
-            <a:off x="640080" y="1691640"/>
-            <a:ext cx="10972800" cy="502920"/>
+            <a:off x="640080" y="1645920"/>
+            <a:ext cx="10972800" cy="411480"/>
           </a:xfrm>
           <a:prstGeom prst="rect">
             <a:avLst/>
@@ -4392,22 +4392,57 @@
                 </a:solidFill>
                 <a:latin typeface="Calibri"/>
               </a:rPr>
-              <a:t>Faustregel: 20–30 konfiguriert, &lt; 10 aktiv / &lt; 80 Tools. Ungenutztes mit /mcp deaktivieren.</a:t>
+              <a:t>Faustregel: &lt; 10 MCPs aktiv / &lt; 80 Tools. Ungenutztes mit /mcp deaktivieren.</a:t>
+            </a:r>
+          </a:p>
+        </p:txBody>
+      </p:sp>
+      <p:sp>
+        <p:nvSpPr>
+          <p:cNvPr id="8" name="TextBox 7"/>
+          <p:cNvSpPr txBox="1"/>
+          <p:nvPr/>
+        </p:nvSpPr>
+        <p:spPr>
+          <a:xfrm>
+            <a:off x="640080" y="2103120"/>
+            <a:ext cx="10972800" cy="347472"/>
+          </a:xfrm>
+          <a:prstGeom prst="rect">
+            <a:avLst/>
+          </a:prstGeom>
+          <a:noFill/>
+        </p:spPr>
+        <p:txBody>
+          <a:bodyPr wrap="square">
+            <a:spAutoFit/>
+          </a:bodyPr>
+          <a:lstStyle/>
+          <a:p>
+            <a:pPr algn="l"/>
+            <a:r>
+              <a:rPr sz="1300" b="1">
+                <a:solidFill>
+                  <a:srgbClr val="22D3EE"/>
+                </a:solidFill>
+                <a:latin typeface="Calibri"/>
+              </a:rPr>
+              <a:t>● BEI DIR AKTIV</a:t>
             </a:r>
           </a:p>
         </p:txBody>
       </p:sp>
       <p:graphicFrame>
         <p:nvGraphicFramePr>
-          <p:cNvPr id="8" name="Table 7"/>
+          <p:cNvPr id="9" name="Table 8"/>
           <p:cNvGraphicFramePr>
             <a:graphicFrameLocks noGrp="1"/>
           </p:cNvGraphicFramePr>
           <p:nvPr/>
         </p:nvGraphicFramePr>
         <p:xfrm>
-          <a:off x="548640" y="2286000"/>
-          <a:ext cx="11155680" cy="4114800"/>
+          <a:off x="548640" y="2487168"/>
+          <a:ext cx="11155680" cy="3063240"/>
         </p:xfrm>
         <a:graphic>
           <a:graphicData uri="http://schemas.openxmlformats.org/drawingml/2006/table">
@@ -4416,11 +4451,11 @@
                 <a:tableStyleId>{2D5ABB26-0587-4C30-8999-92F81FD0307C}</a:tableStyleId>
               </a:tblPr>
               <a:tblGrid>
-                <a:gridCol w="3474720"/>
-                <a:gridCol w="2560320"/>
-                <a:gridCol w="5120640"/>
+                <a:gridCol w="3108960"/>
+                <a:gridCol w="2651760"/>
+                <a:gridCol w="5394960"/>
               </a:tblGrid>
-              <a:tr h="411480">
+              <a:tr h="437605">
                 <a:tc>
                   <a:txBody>
                     <a:bodyPr wrap="square"/>
@@ -4488,7 +4523,7 @@
                   </a:tcPr>
                 </a:tc>
               </a:tr>
-              <a:tr h="411480">
+              <a:tr h="437605">
                 <a:tc>
                   <a:txBody>
                     <a:bodyPr wrap="square"/>
@@ -4501,279 +4536,7 @@
                           </a:solidFill>
                           <a:latin typeface="Calibri"/>
                         </a:rPr>
-                        <a:t>Aktuelle Library-/API-Doku</a:t>
-                      </a:r>
-                    </a:p>
-                  </a:txBody>
-                  <a:tcPr marT="36576" marB="36576" marL="73152" marR="73152">
-                    <a:solidFill>
-                      <a:srgbClr val="141A2E"/>
-                    </a:solidFill>
-                  </a:tcPr>
-                </a:tc>
-                <a:tc>
-                  <a:txBody>
-                    <a:bodyPr wrap="square"/>
-                    <a:lstStyle/>
-                    <a:p>
-                      <a:r>
-                        <a:rPr sz="1100">
-                          <a:solidFill>
-                            <a:srgbClr val="E6EDF8"/>
-                          </a:solidFill>
-                          <a:latin typeface="Calibri"/>
-                        </a:rPr>
-                        <a:t>context7</a:t>
-                      </a:r>
-                    </a:p>
-                  </a:txBody>
-                  <a:tcPr marT="36576" marB="36576" marL="73152" marR="73152">
-                    <a:solidFill>
-                      <a:srgbClr val="141A2E"/>
-                    </a:solidFill>
-                  </a:tcPr>
-                </a:tc>
-                <a:tc>
-                  <a:txBody>
-                    <a:bodyPr wrap="square"/>
-                    <a:lstStyle/>
-                    <a:p>
-                      <a:r>
-                        <a:rPr sz="1100">
-                          <a:solidFill>
-                            <a:srgbClr val="E6EDF8"/>
-                          </a:solidFill>
-                          <a:latin typeface="Calibri"/>
-                        </a:rPr>
-                        <a:t>React, Prisma, Next.js … statt veraltetem Wissen</a:t>
-                      </a:r>
-                    </a:p>
-                  </a:txBody>
-                  <a:tcPr marT="36576" marB="36576" marL="73152" marR="73152">
-                    <a:solidFill>
-                      <a:srgbClr val="141A2E"/>
-                    </a:solidFill>
-                  </a:tcPr>
-                </a:tc>
-              </a:tr>
-              <a:tr h="411480">
-                <a:tc>
-                  <a:txBody>
-                    <a:bodyPr wrap="square"/>
-                    <a:lstStyle/>
-                    <a:p>
-                      <a:r>
-                        <a:rPr sz="1100">
-                          <a:solidFill>
-                            <a:srgbClr val="E6EDF8"/>
-                          </a:solidFill>
-                          <a:latin typeface="Calibri"/>
-                        </a:rPr>
-                        <a:t>Web-Recherche / Discovery</a:t>
-                      </a:r>
-                    </a:p>
-                  </a:txBody>
-                  <a:tcPr marT="36576" marB="36576" marL="73152" marR="73152">
-                    <a:solidFill>
-                      <a:srgbClr val="0A0E1A"/>
-                    </a:solidFill>
-                  </a:tcPr>
-                </a:tc>
-                <a:tc>
-                  <a:txBody>
-                    <a:bodyPr wrap="square"/>
-                    <a:lstStyle/>
-                    <a:p>
-                      <a:r>
-                        <a:rPr sz="1100">
-                          <a:solidFill>
-                            <a:srgbClr val="E6EDF8"/>
-                          </a:solidFill>
-                          <a:latin typeface="Calibri"/>
-                        </a:rPr>
-                        <a:t>exa</a:t>
-                      </a:r>
-                    </a:p>
-                  </a:txBody>
-                  <a:tcPr marT="36576" marB="36576" marL="73152" marR="73152">
-                    <a:solidFill>
-                      <a:srgbClr val="0A0E1A"/>
-                    </a:solidFill>
-                  </a:tcPr>
-                </a:tc>
-                <a:tc>
-                  <a:txBody>
-                    <a:bodyPr wrap="square"/>
-                    <a:lstStyle/>
-                    <a:p>
-                      <a:r>
-                        <a:rPr sz="1100">
-                          <a:solidFill>
-                            <a:srgbClr val="E6EDF8"/>
-                          </a:solidFill>
-                          <a:latin typeface="Calibri"/>
-                        </a:rPr>
-                        <a:t>breite Suche, wenn GitHub+Docs nicht reichen</a:t>
-                      </a:r>
-                    </a:p>
-                  </a:txBody>
-                  <a:tcPr marT="36576" marB="36576" marL="73152" marR="73152">
-                    <a:solidFill>
-                      <a:srgbClr val="0A0E1A"/>
-                    </a:solidFill>
-                  </a:tcPr>
-                </a:tc>
-              </a:tr>
-              <a:tr h="411480">
-                <a:tc>
-                  <a:txBody>
-                    <a:bodyPr wrap="square"/>
-                    <a:lstStyle/>
-                    <a:p>
-                      <a:r>
-                        <a:rPr sz="1100">
-                          <a:solidFill>
-                            <a:srgbClr val="E6EDF8"/>
-                          </a:solidFill>
-                          <a:latin typeface="Calibri"/>
-                        </a:rPr>
-                        <a:t>GitHub (PRs, Issues, Code-Suche)</a:t>
-                      </a:r>
-                    </a:p>
-                  </a:txBody>
-                  <a:tcPr marT="36576" marB="36576" marL="73152" marR="73152">
-                    <a:solidFill>
-                      <a:srgbClr val="141A2E"/>
-                    </a:solidFill>
-                  </a:tcPr>
-                </a:tc>
-                <a:tc>
-                  <a:txBody>
-                    <a:bodyPr wrap="square"/>
-                    <a:lstStyle/>
-                    <a:p>
-                      <a:r>
-                        <a:rPr sz="1100">
-                          <a:solidFill>
-                            <a:srgbClr val="E6EDF8"/>
-                          </a:solidFill>
-                          <a:latin typeface="Calibri"/>
-                        </a:rPr>
-                        <a:t>github</a:t>
-                      </a:r>
-                    </a:p>
-                  </a:txBody>
-                  <a:tcPr marT="36576" marB="36576" marL="73152" marR="73152">
-                    <a:solidFill>
-                      <a:srgbClr val="141A2E"/>
-                    </a:solidFill>
-                  </a:tcPr>
-                </a:tc>
-                <a:tc>
-                  <a:txBody>
-                    <a:bodyPr wrap="square"/>
-                    <a:lstStyle/>
-                    <a:p>
-                      <a:r>
-                        <a:rPr sz="1100">
-                          <a:solidFill>
-                            <a:srgbClr val="E6EDF8"/>
-                          </a:solidFill>
-                          <a:latin typeface="Calibri"/>
-                        </a:rPr>
-                        <a:t>Code-Search FIRST vor Neuschreiben</a:t>
-                      </a:r>
-                    </a:p>
-                  </a:txBody>
-                  <a:tcPr marT="36576" marB="36576" marL="73152" marR="73152">
-                    <a:solidFill>
-                      <a:srgbClr val="141A2E"/>
-                    </a:solidFill>
-                  </a:tcPr>
-                </a:tc>
-              </a:tr>
-              <a:tr h="411480">
-                <a:tc>
-                  <a:txBody>
-                    <a:bodyPr wrap="square"/>
-                    <a:lstStyle/>
-                    <a:p>
-                      <a:r>
-                        <a:rPr sz="1100">
-                          <a:solidFill>
-                            <a:srgbClr val="E6EDF8"/>
-                          </a:solidFill>
-                          <a:latin typeface="Calibri"/>
-                        </a:rPr>
-                        <a:t>Browser / E2E / Screenshots</a:t>
-                      </a:r>
-                    </a:p>
-                  </a:txBody>
-                  <a:tcPr marT="36576" marB="36576" marL="73152" marR="73152">
-                    <a:solidFill>
-                      <a:srgbClr val="0A0E1A"/>
-                    </a:solidFill>
-                  </a:tcPr>
-                </a:tc>
-                <a:tc>
-                  <a:txBody>
-                    <a:bodyPr wrap="square"/>
-                    <a:lstStyle/>
-                    <a:p>
-                      <a:r>
-                        <a:rPr sz="1100">
-                          <a:solidFill>
-                            <a:srgbClr val="E6EDF8"/>
-                          </a:solidFill>
-                          <a:latin typeface="Calibri"/>
-                        </a:rPr>
-                        <a:t>playwright</a:t>
-                      </a:r>
-                    </a:p>
-                  </a:txBody>
-                  <a:tcPr marT="36576" marB="36576" marL="73152" marR="73152">
-                    <a:solidFill>
-                      <a:srgbClr val="0A0E1A"/>
-                    </a:solidFill>
-                  </a:tcPr>
-                </a:tc>
-                <a:tc>
-                  <a:txBody>
-                    <a:bodyPr wrap="square"/>
-                    <a:lstStyle/>
-                    <a:p>
-                      <a:r>
-                        <a:rPr sz="1100">
-                          <a:solidFill>
-                            <a:srgbClr val="E6EDF8"/>
-                          </a:solidFill>
-                          <a:latin typeface="Calibri"/>
-                        </a:rPr>
-                        <a:t>headless Automation, visuelle Tests</a:t>
-                      </a:r>
-                    </a:p>
-                  </a:txBody>
-                  <a:tcPr marT="36576" marB="36576" marL="73152" marR="73152">
-                    <a:solidFill>
-                      <a:srgbClr val="0A0E1A"/>
-                    </a:solidFill>
-                  </a:tcPr>
-                </a:tc>
-              </a:tr>
-              <a:tr h="411480">
-                <a:tc>
-                  <a:txBody>
-                    <a:bodyPr wrap="square"/>
-                    <a:lstStyle/>
-                    <a:p>
-                      <a:r>
-                        <a:rPr sz="1100">
-                          <a:solidFill>
-                            <a:srgbClr val="E6EDF8"/>
-                          </a:solidFill>
-                          <a:latin typeface="Calibri"/>
-                        </a:rPr>
-                        <a:t>PDF / Word / Excel lesen</a:t>
+                        <a:t>PDF/Word/Excel/PPTX lesen</a:t>
                       </a:r>
                     </a:p>
                   </a:txBody>
@@ -4817,7 +4580,7 @@
                           </a:solidFill>
                           <a:latin typeface="Calibri"/>
                         </a:rPr>
-                        <a:t>Dokumente → Markdown (global aktiv)</a:t>
+                        <a:t>Dokumente → Markdown (lokal, global aktiv)</a:t>
                       </a:r>
                     </a:p>
                   </a:txBody>
@@ -4828,7 +4591,7 @@
                   </a:tcPr>
                 </a:tc>
               </a:tr>
-              <a:tr h="411480">
+              <a:tr h="437605">
                 <a:tc>
                   <a:txBody>
                     <a:bodyPr wrap="square"/>
@@ -4841,7 +4604,7 @@
                           </a:solidFill>
                           <a:latin typeface="Calibri"/>
                         </a:rPr>
-                        <a:t>Strukturierter Wissensgraph</a:t>
+                        <a:t>Aktuelle Library-/API-Doku</a:t>
                       </a:r>
                     </a:p>
                   </a:txBody>
@@ -4863,7 +4626,7 @@
                           </a:solidFill>
                           <a:latin typeface="Calibri"/>
                         </a:rPr>
-                        <a:t>memory</a:t>
+                        <a:t>context7</a:t>
                       </a:r>
                     </a:p>
                   </a:txBody>
@@ -4885,7 +4648,7 @@
                           </a:solidFill>
                           <a:latin typeface="Calibri"/>
                         </a:rPr>
-                        <a:t>Laufzeit-Memory (mit claude-mem abstimmen)</a:t>
+                        <a:t>React, Prisma, Next.js … statt veraltetem Wissen (Plugin)</a:t>
                       </a:r>
                     </a:p>
                   </a:txBody>
@@ -4896,7 +4659,7 @@
                   </a:tcPr>
                 </a:tc>
               </a:tr>
-              <a:tr h="411480">
+              <a:tr h="437605">
                 <a:tc>
                   <a:txBody>
                     <a:bodyPr wrap="square"/>
@@ -4909,7 +4672,7 @@
                           </a:solidFill>
                           <a:latin typeface="Calibri"/>
                         </a:rPr>
-                        <a:t>Schrittweises Reasoning</a:t>
+                        <a:t>Frühere Arbeit / „schon gelöst?“</a:t>
                       </a:r>
                     </a:p>
                   </a:txBody>
@@ -4931,7 +4694,7 @@
                           </a:solidFill>
                           <a:latin typeface="Calibri"/>
                         </a:rPr>
-                        <a:t>sequential-thinking</a:t>
+                        <a:t>claude-mem</a:t>
                       </a:r>
                     </a:p>
                   </a:txBody>
@@ -4953,7 +4716,7 @@
                           </a:solidFill>
                           <a:latin typeface="Calibri"/>
                         </a:rPr>
-                        <a:t>komplexe Mehrschritt-Probleme</a:t>
+                        <a:t>deine Memory-Quelle: /mem-search, Auto-Injektion ab 2. Session</a:t>
                       </a:r>
                     </a:p>
                   </a:txBody>
@@ -4964,7 +4727,7 @@
                   </a:tcPr>
                 </a:tc>
               </a:tr>
-              <a:tr h="411480">
+              <a:tr h="437605">
                 <a:tc>
                   <a:txBody>
                     <a:bodyPr wrap="square"/>
@@ -4977,7 +4740,7 @@
                           </a:solidFill>
                           <a:latin typeface="Calibri"/>
                         </a:rPr>
-                        <a:t>Bash-Token sparen (lokal)</a:t>
+                        <a:t>Kontext-Tooling</a:t>
                       </a:r>
                     </a:p>
                   </a:txBody>
@@ -4999,7 +4762,143 @@
                           </a:solidFill>
                           <a:latin typeface="Calibri"/>
                         </a:rPr>
-                        <a:t>RTK-Hook</a:t>
+                        <a:t>context-mode</a:t>
+                      </a:r>
+                    </a:p>
+                  </a:txBody>
+                  <a:tcPr marT="36576" marB="36576" marL="73152" marR="73152">
+                    <a:solidFill>
+                      <a:srgbClr val="0A0E1A"/>
+                    </a:solidFill>
+                  </a:tcPr>
+                </a:tc>
+                <a:tc>
+                  <a:txBody>
+                    <a:bodyPr wrap="square"/>
+                    <a:lstStyle/>
+                    <a:p>
+                      <a:r>
+                        <a:rPr sz="1100">
+                          <a:solidFill>
+                            <a:srgbClr val="E6EDF8"/>
+                          </a:solidFill>
+                          <a:latin typeface="Calibri"/>
+                        </a:rPr>
+                        <a:t>lokaler MCP</a:t>
+                      </a:r>
+                    </a:p>
+                  </a:txBody>
+                  <a:tcPr marT="36576" marB="36576" marL="73152" marR="73152">
+                    <a:solidFill>
+                      <a:srgbClr val="0A0E1A"/>
+                    </a:solidFill>
+                  </a:tcPr>
+                </a:tc>
+              </a:tr>
+              <a:tr h="437605">
+                <a:tc>
+                  <a:txBody>
+                    <a:bodyPr wrap="square"/>
+                    <a:lstStyle/>
+                    <a:p>
+                      <a:r>
+                        <a:rPr sz="1100">
+                          <a:solidFill>
+                            <a:srgbClr val="E6EDF8"/>
+                          </a:solidFill>
+                          <a:latin typeface="Calibri"/>
+                        </a:rPr>
+                        <a:t>Dienste anbinden</a:t>
+                      </a:r>
+                    </a:p>
+                  </a:txBody>
+                  <a:tcPr marT="36576" marB="36576" marL="73152" marR="73152">
+                    <a:solidFill>
+                      <a:srgbClr val="141A2E"/>
+                    </a:solidFill>
+                  </a:tcPr>
+                </a:tc>
+                <a:tc>
+                  <a:txBody>
+                    <a:bodyPr wrap="square"/>
+                    <a:lstStyle/>
+                    <a:p>
+                      <a:r>
+                        <a:rPr sz="1100">
+                          <a:solidFill>
+                            <a:srgbClr val="E6EDF8"/>
+                          </a:solidFill>
+                          <a:latin typeface="Calibri"/>
+                        </a:rPr>
+                        <a:t>claude.ai-Connectoren</a:t>
+                      </a:r>
+                    </a:p>
+                  </a:txBody>
+                  <a:tcPr marT="36576" marB="36576" marL="73152" marR="73152">
+                    <a:solidFill>
+                      <a:srgbClr val="141A2E"/>
+                    </a:solidFill>
+                  </a:tcPr>
+                </a:tc>
+                <a:tc>
+                  <a:txBody>
+                    <a:bodyPr wrap="square"/>
+                    <a:lstStyle/>
+                    <a:p>
+                      <a:r>
+                        <a:rPr sz="1100">
+                          <a:solidFill>
+                            <a:srgbClr val="E6EDF8"/>
+                          </a:solidFill>
+                          <a:latin typeface="Calibri"/>
+                        </a:rPr>
+                        <a:t>n8n · Notion · Gamma · Google Drive · Microsoft Learn · Kiwi</a:t>
+                      </a:r>
+                    </a:p>
+                  </a:txBody>
+                  <a:tcPr marT="36576" marB="36576" marL="73152" marR="73152">
+                    <a:solidFill>
+                      <a:srgbClr val="141A2E"/>
+                    </a:solidFill>
+                  </a:tcPr>
+                </a:tc>
+              </a:tr>
+              <a:tr h="437610">
+                <a:tc>
+                  <a:txBody>
+                    <a:bodyPr wrap="square"/>
+                    <a:lstStyle/>
+                    <a:p>
+                      <a:r>
+                        <a:rPr sz="1100">
+                          <a:solidFill>
+                            <a:srgbClr val="E6EDF8"/>
+                          </a:solidFill>
+                          <a:latin typeface="Calibri"/>
+                        </a:rPr>
+                        <a:t>Bash-Token sparen</a:t>
+                      </a:r>
+                    </a:p>
+                  </a:txBody>
+                  <a:tcPr marT="36576" marB="36576" marL="73152" marR="73152">
+                    <a:solidFill>
+                      <a:srgbClr val="0A0E1A"/>
+                    </a:solidFill>
+                  </a:tcPr>
+                </a:tc>
+                <a:tc>
+                  <a:txBody>
+                    <a:bodyPr wrap="square"/>
+                    <a:lstStyle/>
+                    <a:p>
+                      <a:r>
+                        <a:rPr sz="1100">
+                          <a:solidFill>
+                            <a:srgbClr val="E6EDF8"/>
+                          </a:solidFill>
+                          <a:latin typeface="Calibri"/>
+                        </a:rPr>
+                        <a:t>RTK (Hook, kein MCP)</a:t>
                       </a:r>
                     </a:p>
                   </a:txBody>
@@ -5032,78 +4931,57 @@
                   </a:tcPr>
                 </a:tc>
               </a:tr>
-              <a:tr h="411480">
-                <a:tc>
-                  <a:txBody>
-                    <a:bodyPr wrap="square"/>
-                    <a:lstStyle/>
-                    <a:p>
-                      <a:r>
-                        <a:rPr sz="1100">
-                          <a:solidFill>
-                            <a:srgbClr val="E6EDF8"/>
-                          </a:solidFill>
-                          <a:latin typeface="Calibri"/>
-                        </a:rPr>
-                        <a:t>Frühere Arbeit / „schon gelöst?"</a:t>
-                      </a:r>
-                    </a:p>
-                  </a:txBody>
-                  <a:tcPr marT="36576" marB="36576" marL="73152" marR="73152">
-                    <a:solidFill>
-                      <a:srgbClr val="141A2E"/>
-                    </a:solidFill>
-                  </a:tcPr>
-                </a:tc>
-                <a:tc>
-                  <a:txBody>
-                    <a:bodyPr wrap="square"/>
-                    <a:lstStyle/>
-                    <a:p>
-                      <a:r>
-                        <a:rPr sz="1100">
-                          <a:solidFill>
-                            <a:srgbClr val="E6EDF8"/>
-                          </a:solidFill>
-                          <a:latin typeface="Calibri"/>
-                        </a:rPr>
-                        <a:t>claude-mem (/mem-search)</a:t>
-                      </a:r>
-                    </a:p>
-                  </a:txBody>
-                  <a:tcPr marT="36576" marB="36576" marL="73152" marR="73152">
-                    <a:solidFill>
-                      <a:srgbClr val="141A2E"/>
-                    </a:solidFill>
-                  </a:tcPr>
-                </a:tc>
-                <a:tc>
-                  <a:txBody>
-                    <a:bodyPr wrap="square"/>
-                    <a:lstStyle/>
-                    <a:p>
-                      <a:r>
-                        <a:rPr sz="1100">
-                          <a:solidFill>
-                            <a:srgbClr val="E6EDF8"/>
-                          </a:solidFill>
-                          <a:latin typeface="Calibri"/>
-                        </a:rPr>
-                        <a:t>cross-session Memory, injiziert Kontext automatisch</a:t>
-                      </a:r>
-                    </a:p>
-                  </a:txBody>
-                  <a:tcPr marT="36576" marB="36576" marL="73152" marR="73152">
-                    <a:solidFill>
-                      <a:srgbClr val="141A2E"/>
-                    </a:solidFill>
-                  </a:tcPr>
-                </a:tc>
-              </a:tr>
             </a:tbl>
           </a:graphicData>
         </a:graphic>
       </p:graphicFrame>
+      <p:sp>
+        <p:nvSpPr>
+          <p:cNvPr id="10" name="TextBox 9"/>
+          <p:cNvSpPr txBox="1"/>
+          <p:nvPr/>
+        </p:nvSpPr>
+        <p:spPr>
+          <a:xfrm>
+            <a:off x="640080" y="5669280"/>
+            <a:ext cx="10972800" cy="960120"/>
+          </a:xfrm>
+          <a:prstGeom prst="rect">
+            <a:avLst/>
+          </a:prstGeom>
+          <a:noFill/>
+        </p:spPr>
+        <p:txBody>
+          <a:bodyPr wrap="none">
+            <a:spAutoFit/>
+          </a:bodyPr>
+          <a:lstStyle/>
+          <a:p>
+            <a:pPr algn="l"/>
+            <a:r>
+              <a:rPr sz="1300" b="0">
+                <a:solidFill>
+                  <a:srgbClr val="8B98B0"/>
+                </a:solidFill>
+                <a:latin typeface="Calibri"/>
+              </a:rPr>
+              <a:t>Optional, NICHT installiert: exa · github (du: gh-CLI) · playwright · sequential-thinking.</a:t>
+            </a:r>
+          </a:p>
+          <a:p>
+            <a:pPr algn="l"/>
+            <a:r>
+              <a:rPr sz="1300" b="1">
+                <a:solidFill>
+                  <a:srgbClr val="FBBF24"/>
+                </a:solidFill>
+                <a:latin typeface="Calibri"/>
+              </a:rPr>
+              <a:t>„memory“-MCP (Wissensgraph) nicht nötig — claude-mem ist deine Memory-Quelle.</a:t>
+            </a:r>
+          </a:p>
+        </p:txBody>
+      </p:sp>
     </p:spTree>
   </p:cSld>
   <p:clrMapOvr>
@@ -6270,8 +6148,8 @@
         </p:nvSpPr>
         <p:spPr>
           <a:xfrm>
-            <a:off x="640080" y="4846320"/>
-            <a:ext cx="10972800" cy="1280160"/>
+            <a:off x="640080" y="4754880"/>
+            <a:ext cx="10972800" cy="1554480"/>
           </a:xfrm>
           <a:prstGeom prst="rect">
             <a:avLst/>
@@ -6286,19 +6164,31 @@
           <a:p>
             <a:pPr algn="l"/>
             <a:r>
-              <a:rPr sz="1500" b="1">
+              <a:rPr sz="1400" b="1">
+                <a:solidFill>
+                  <a:srgbClr val="E6EDF8"/>
+                </a:solidFill>
+                <a:latin typeface="Calibri"/>
+              </a:rPr>
+              <a:t>claude-mem = deine Memory-Quelle: Auto-Injektion ab 2. Session · /mem-search für frühere Arbeit.</a:t>
+            </a:r>
+          </a:p>
+          <a:p>
+            <a:pPr algn="l"/>
+            <a:r>
+              <a:rPr sz="1400" b="1">
                 <a:solidFill>
                   <a:srgbClr val="FBBF24"/>
                 </a:solidFill>
                 <a:latin typeface="Calibri"/>
               </a:rPr>
-              <a:t>EINE primäre Memory-Quelle je Projekt (claude-mem-Koexistenz). Keine Secrets in Memory.</a:t>
-            </a:r>
-          </a:p>
-          <a:p>
-            <a:pPr algn="l"/>
-            <a:r>
-              <a:rPr sz="1400" b="0">
+              <a:t>EINE primäre Memory-Quelle je Projekt — kein zusätzlicher memory-MCP. Keine Secrets in Memory.</a:t>
+            </a:r>
+          </a:p>
+          <a:p>
+            <a:pPr algn="l"/>
+            <a:r>
+              <a:rPr sz="1300" b="0">
                 <a:solidFill>
                   <a:srgbClr val="818CF8"/>
                 </a:solidFill>

</xml_diff>

<commit_message>
docs: Hybrid-Mega-Workflow + Begleit-Guide-Kapitel (Schritt 4)
- docs/MEGA-WORKFLOW.de.md: Speicherorte, Sync-Loop (PRE/POST),
  RPI+ECC-Orchestrierung, neu vs. bestehend, Recovery, Spickzettel
- build_guide.py: Kapitel "16 - Hybrid-Mega-Workflow" (docx) + eine
  pptx-Slide (Denominator 18 -> 19); Quellen-Kapitel auf 17/19 verschoben
- Office-Dateien (.docx/.pptx) neu gebaut

Co-Authored-By: Claude Opus 4.8 (1M context) <noreply@anthropic.com>
</commit_message>
<xml_diff>
--- a/docs/ECC-Harness-Guide.de.pptx
+++ b/docs/ECC-Harness-Guide.de.pptx
@@ -24,6 +24,7 @@
     <p:sldId id="272" r:id="rId23"/>
     <p:sldId id="273" r:id="rId24"/>
     <p:sldId id="274" r:id="rId25"/>
+    <p:sldId id="275" r:id="rId26"/>
   </p:sldIdLst>
   <p:sldSz cx="12191695" cy="6858000" type="screen4x3"/>
   <p:notesSz cx="6858000" cy="9144000"/>
@@ -3422,7 +3423,7 @@
                 </a:solidFill>
                 <a:latin typeface="Calibri"/>
               </a:rPr>
-              <a:t>9 / 18</a:t>
+              <a:t>9 / 19</a:t>
             </a:r>
           </a:p>
         </p:txBody>
@@ -4123,7 +4124,7 @@
                 </a:solidFill>
                 <a:latin typeface="Calibri"/>
               </a:rPr>
-              <a:t>10 / 18</a:t>
+              <a:t>10 / 19</a:t>
             </a:r>
           </a:p>
         </p:txBody>
@@ -4981,7 +4982,7 @@
                 </a:solidFill>
                 <a:latin typeface="Calibri"/>
               </a:rPr>
-              <a:t>11 / 18</a:t>
+              <a:t>11 / 19</a:t>
             </a:r>
           </a:p>
         </p:txBody>
@@ -5839,7 +5840,7 @@
                 </a:solidFill>
                 <a:latin typeface="Calibri"/>
               </a:rPr>
-              <a:t>12 / 18</a:t>
+              <a:t>12 / 19</a:t>
             </a:r>
           </a:p>
         </p:txBody>
@@ -6678,7 +6679,7 @@
                 </a:solidFill>
                 <a:latin typeface="Calibri"/>
               </a:rPr>
-              <a:t>13 / 18</a:t>
+              <a:t>13 / 19</a:t>
             </a:r>
           </a:p>
         </p:txBody>
@@ -7361,7 +7362,7 @@
                 </a:solidFill>
                 <a:latin typeface="Calibri"/>
               </a:rPr>
-              <a:t>14 / 18</a:t>
+              <a:t>14 / 19</a:t>
             </a:r>
           </a:p>
         </p:txBody>
@@ -7895,7 +7896,7 @@
                 </a:solidFill>
                 <a:latin typeface="Calibri"/>
               </a:rPr>
-              <a:t>15 / 18</a:t>
+              <a:t>15 / 19</a:t>
             </a:r>
           </a:p>
         </p:txBody>
@@ -8575,7 +8576,7 @@
                 </a:solidFill>
                 <a:latin typeface="Calibri"/>
               </a:rPr>
-              <a:t>16 / 18</a:t>
+              <a:t>16 / 19</a:t>
             </a:r>
           </a:p>
         </p:txBody>
@@ -9163,7 +9164,7 @@
                 </a:solidFill>
                 <a:latin typeface="Calibri"/>
               </a:rPr>
-              <a:t>17 / 18</a:t>
+              <a:t>17 / 19</a:t>
             </a:r>
           </a:p>
         </p:txBody>
@@ -9511,7 +9512,7 @@
                 </a:solidFill>
                 <a:latin typeface="Calibri"/>
               </a:rPr>
-              <a:t>QUELLEN</a:t>
+              <a:t>HYBRID-LOOP</a:t>
             </a:r>
           </a:p>
         </p:txBody>
@@ -9546,7 +9547,7 @@
                 </a:solidFill>
                 <a:latin typeface="Calibri"/>
               </a:rPr>
-              <a:t>18 / 18</a:t>
+              <a:t>18 / 19</a:t>
             </a:r>
           </a:p>
         </p:txBody>
@@ -9581,7 +9582,7 @@
                 </a:solidFill>
                 <a:latin typeface="Calibri"/>
               </a:rPr>
-              <a:t>Quellen &amp; TL;DR</a:t>
+              <a:t>§16 Hybrid-Mega-Workflow — State-Sync + RPI</a:t>
             </a:r>
           </a:p>
         </p:txBody>
@@ -9638,8 +9639,89 @@
         </p:nvSpPr>
         <p:spPr>
           <a:xfrm>
-            <a:off x="640080" y="1737360"/>
-            <a:ext cx="10972800" cy="1554480"/>
+            <a:off x="640080" y="1645920"/>
+            <a:ext cx="10972800" cy="457200"/>
+          </a:xfrm>
+          <a:prstGeom prst="rect">
+            <a:avLst/>
+          </a:prstGeom>
+          <a:noFill/>
+        </p:spPr>
+        <p:txBody>
+          <a:bodyPr wrap="square">
+            <a:spAutoFit/>
+          </a:bodyPr>
+          <a:lstStyle/>
+          <a:p>
+            <a:pPr algn="l"/>
+            <a:r>
+              <a:rPr sz="1400" b="1">
+                <a:solidFill>
+                  <a:srgbClr val="FBBF24"/>
+                </a:solidFill>
+                <a:latin typeface="Calibri"/>
+              </a:rPr>
+              <a:t>state/ ist die Wahrheit · WORKING-CONTEXT.md ist ihr generiertes Spiegelbild für den Loop.</a:t>
+            </a:r>
+          </a:p>
+        </p:txBody>
+      </p:sp>
+      <p:sp>
+        <p:nvSpPr>
+          <p:cNvPr id="8" name="Rounded Rectangle 7"/>
+          <p:cNvSpPr/>
+          <p:nvPr/>
+        </p:nvSpPr>
+        <p:spPr>
+          <a:xfrm>
+            <a:off x="640080" y="2194560"/>
+            <a:ext cx="10927080" cy="1600200"/>
+          </a:xfrm>
+          <a:prstGeom prst="roundRect">
+            <a:avLst>
+              <a:gd name="adj" fmla="val 6000"/>
+            </a:avLst>
+          </a:prstGeom>
+          <a:solidFill>
+            <a:srgbClr val="0E1424"/>
+          </a:solidFill>
+          <a:ln>
+            <a:noFill/>
+          </a:ln>
+          <a:effectLst/>
+        </p:spPr>
+        <p:style>
+          <a:lnRef idx="1">
+            <a:schemeClr val="accent1"/>
+          </a:lnRef>
+          <a:fillRef idx="3">
+            <a:schemeClr val="accent1"/>
+          </a:fillRef>
+          <a:effectRef idx="2">
+            <a:schemeClr val="accent1"/>
+          </a:effectRef>
+          <a:fontRef idx="minor">
+            <a:schemeClr val="lt1"/>
+          </a:fontRef>
+        </p:style>
+        <p:txBody>
+          <a:bodyPr rtlCol="0" anchor="ctr"/>
+          <a:lstStyle/>
+          <a:p>
+            <a:pPr algn="ctr"/>
+          </a:p>
+        </p:txBody>
+      </p:sp>
+      <p:sp>
+        <p:nvSpPr>
+          <p:cNvPr id="9" name="TextBox 8"/>
+          <p:cNvSpPr txBox="1"/>
+          <p:nvPr/>
+        </p:nvSpPr>
+        <p:spPr>
+          <a:xfrm>
+            <a:off x="914400" y="2377440"/>
+            <a:ext cx="10424160" cy="1280160"/>
           </a:xfrm>
           <a:prstGeom prst="rect">
             <a:avLst/>
@@ -9654,63 +9736,330 @@
           <a:p>
             <a:pPr algn="l"/>
             <a:r>
+              <a:rPr sz="1200" b="0">
+                <a:solidFill>
+                  <a:srgbClr val="9CE3F0"/>
+                </a:solidFill>
+                <a:latin typeface="Consolas"/>
+              </a:rPr>
+              <a:t>state/*.md   --PRE (SessionStart)--&gt;   WORKING-CONTEXT.md   (Loop: liest STATE:*, fuellt SYNC:*)</a:t>
+            </a:r>
+          </a:p>
+          <a:p>
+            <a:pPr algn="l"/>
+            <a:r>
+              <a:rPr sz="1200" b="0">
+                <a:solidFill>
+                  <a:srgbClr val="9CE3F0"/>
+                </a:solidFill>
+                <a:latin typeface="Consolas"/>
+              </a:rPr>
+              <a:t>WORKING-CONTEXT.md   --POST (Stop/PreCompact)--&gt;   state/progress.md + tasks.md   (nur Delta)</a:t>
+            </a:r>
+          </a:p>
+        </p:txBody>
+      </p:sp>
+      <p:sp>
+        <p:nvSpPr>
+          <p:cNvPr id="10" name="TextBox 9"/>
+          <p:cNvSpPr txBox="1"/>
+          <p:nvPr/>
+        </p:nvSpPr>
+        <p:spPr>
+          <a:xfrm>
+            <a:off x="640080" y="3977639"/>
+            <a:ext cx="10972800" cy="365760"/>
+          </a:xfrm>
+          <a:prstGeom prst="rect">
+            <a:avLst/>
+          </a:prstGeom>
+          <a:noFill/>
+        </p:spPr>
+        <p:txBody>
+          <a:bodyPr wrap="square">
+            <a:spAutoFit/>
+          </a:bodyPr>
+          <a:lstStyle/>
+          <a:p>
+            <a:pPr algn="l"/>
+            <a:r>
               <a:rPr sz="1400" b="1">
                 <a:solidFill>
-                  <a:srgbClr val="22D3EE"/>
-                </a:solidFill>
-                <a:latin typeface="Calibri"/>
-              </a:rPr>
-              <a:t>Guides von @affaanmustafa (X-Threads; lokal unter ecc/):</a:t>
-            </a:r>
-          </a:p>
-          <a:p>
-            <a:pPr algn="l"/>
-            <a:r>
-              <a:rPr sz="1150" b="0">
-                <a:solidFill>
-                  <a:srgbClr val="E6EDF8"/>
-                </a:solidFill>
-                <a:latin typeface="Calibri"/>
-              </a:rPr>
-              <a:t>Shortform: https://x.com/affaanmustafa/status/2012378465664745795</a:t>
-            </a:r>
-          </a:p>
-          <a:p>
-            <a:pPr algn="l"/>
-            <a:r>
-              <a:rPr sz="1150" b="0">
-                <a:solidFill>
-                  <a:srgbClr val="E6EDF8"/>
-                </a:solidFill>
-                <a:latin typeface="Calibri"/>
-              </a:rPr>
-              <a:t>Longform:  https://x.com/affaanmustafa/status/2014040193557471352</a:t>
-            </a:r>
-          </a:p>
-          <a:p>
-            <a:pPr algn="l"/>
-            <a:r>
-              <a:rPr sz="1150" b="0">
-                <a:solidFill>
-                  <a:srgbClr val="E6EDF8"/>
-                </a:solidFill>
-                <a:latin typeface="Calibri"/>
-              </a:rPr>
-              <a:t>Security:  https://x.com/affaanmustafa/status/2033263813387223421</a:t>
-            </a:r>
-          </a:p>
-        </p:txBody>
-      </p:sp>
-      <p:sp>
-        <p:nvSpPr>
-          <p:cNvPr id="8" name="TextBox 7"/>
+                  <a:srgbClr val="818CF8"/>
+                </a:solidFill>
+                <a:latin typeface="Calibri"/>
+              </a:rPr>
+              <a:t>/mega-plan — RPI-Berater PARALLEL (read-only) → Briefing → /plan:</a:t>
+            </a:r>
+          </a:p>
+        </p:txBody>
+      </p:sp>
+      <p:graphicFrame>
+        <p:nvGraphicFramePr>
+          <p:cNvPr id="11" name="Table 10"/>
+          <p:cNvGraphicFramePr>
+            <a:graphicFrameLocks noGrp="1"/>
+          </p:cNvGraphicFramePr>
+          <p:nvPr/>
+        </p:nvGraphicFramePr>
+        <p:xfrm>
+          <a:off x="640080" y="4343400"/>
+          <a:ext cx="10972800" cy="1417320"/>
+        </p:xfrm>
+        <a:graphic>
+          <a:graphicData uri="http://schemas.openxmlformats.org/drawingml/2006/table">
+            <a:tbl>
+              <a:tblPr>
+                <a:tableStyleId>{2D5ABB26-0587-4C30-8999-92F81FD0307C}</a:tableStyleId>
+              </a:tblPr>
+              <a:tblGrid>
+                <a:gridCol w="2194560"/>
+                <a:gridCol w="8778240"/>
+              </a:tblGrid>
+              <a:tr h="283464">
+                <a:tc>
+                  <a:txBody>
+                    <a:bodyPr wrap="square"/>
+                    <a:lstStyle/>
+                    <a:p>
+                      <a:r>
+                        <a:rPr sz="1150" b="1">
+                          <a:solidFill>
+                            <a:srgbClr val="22D3EE"/>
+                          </a:solidFill>
+                          <a:latin typeface="Calibri"/>
+                        </a:rPr>
+                        <a:t>Berater</a:t>
+                      </a:r>
+                    </a:p>
+                  </a:txBody>
+                  <a:tcPr marT="36576" marB="36576" marL="73152" marR="73152">
+                    <a:solidFill>
+                      <a:srgbClr val="0E1424"/>
+                    </a:solidFill>
+                  </a:tcPr>
+                </a:tc>
+                <a:tc>
+                  <a:txBody>
+                    <a:bodyPr wrap="square"/>
+                    <a:lstStyle/>
+                    <a:p>
+                      <a:r>
+                        <a:rPr sz="1150" b="1">
+                          <a:solidFill>
+                            <a:srgbClr val="22D3EE"/>
+                          </a:solidFill>
+                          <a:latin typeface="Calibri"/>
+                        </a:rPr>
+                        <a:t>Perspektive</a:t>
+                      </a:r>
+                    </a:p>
+                  </a:txBody>
+                  <a:tcPr marT="36576" marB="36576" marL="73152" marR="73152">
+                    <a:solidFill>
+                      <a:srgbClr val="0E1424"/>
+                    </a:solidFill>
+                  </a:tcPr>
+                </a:tc>
+              </a:tr>
+              <a:tr h="283464">
+                <a:tc>
+                  <a:txBody>
+                    <a:bodyPr wrap="square"/>
+                    <a:lstStyle/>
+                    <a:p>
+                      <a:r>
+                        <a:rPr sz="1150">
+                          <a:solidFill>
+                            <a:srgbClr val="E6EDF8"/>
+                          </a:solidFill>
+                          <a:latin typeface="Calibri"/>
+                        </a:rPr>
+                        <a:t>Intake</a:t>
+                      </a:r>
+                    </a:p>
+                  </a:txBody>
+                  <a:tcPr marT="36576" marB="36576" marL="73152" marR="73152">
+                    <a:solidFill>
+                      <a:srgbClr val="141A2E"/>
+                    </a:solidFill>
+                  </a:tcPr>
+                </a:tc>
+                <a:tc>
+                  <a:txBody>
+                    <a:bodyPr wrap="square"/>
+                    <a:lstStyle/>
+                    <a:p>
+                      <a:r>
+                        <a:rPr sz="1150">
+                          <a:solidFill>
+                            <a:srgbClr val="E6EDF8"/>
+                          </a:solidFill>
+                          <a:latin typeface="Calibri"/>
+                        </a:rPr>
+                        <a:t>Anforderungen · Constraints · offene Fragen</a:t>
+                      </a:r>
+                    </a:p>
+                  </a:txBody>
+                  <a:tcPr marT="36576" marB="36576" marL="73152" marR="73152">
+                    <a:solidFill>
+                      <a:srgbClr val="141A2E"/>
+                    </a:solidFill>
+                  </a:tcPr>
+                </a:tc>
+              </a:tr>
+              <a:tr h="283464">
+                <a:tc>
+                  <a:txBody>
+                    <a:bodyPr wrap="square"/>
+                    <a:lstStyle/>
+                    <a:p>
+                      <a:r>
+                        <a:rPr sz="1150">
+                          <a:solidFill>
+                            <a:srgbClr val="E6EDF8"/>
+                          </a:solidFill>
+                          <a:latin typeface="Calibri"/>
+                        </a:rPr>
+                        <a:t>CTO</a:t>
+                      </a:r>
+                    </a:p>
+                  </a:txBody>
+                  <a:tcPr marT="36576" marB="36576" marL="73152" marR="73152">
+                    <a:solidFill>
+                      <a:srgbClr val="0A0E1A"/>
+                    </a:solidFill>
+                  </a:tcPr>
+                </a:tc>
+                <a:tc>
+                  <a:txBody>
+                    <a:bodyPr wrap="square"/>
+                    <a:lstStyle/>
+                    <a:p>
+                      <a:r>
+                        <a:rPr sz="1150">
+                          <a:solidFill>
+                            <a:srgbClr val="E6EDF8"/>
+                          </a:solidFill>
+                          <a:latin typeface="Calibri"/>
+                        </a:rPr>
+                        <a:t>Technik-Strategie · Architektur-Fit · Risiko</a:t>
+                      </a:r>
+                    </a:p>
+                  </a:txBody>
+                  <a:tcPr marT="36576" marB="36576" marL="73152" marR="73152">
+                    <a:solidFill>
+                      <a:srgbClr val="0A0E1A"/>
+                    </a:solidFill>
+                  </a:tcPr>
+                </a:tc>
+              </a:tr>
+              <a:tr h="283464">
+                <a:tc>
+                  <a:txBody>
+                    <a:bodyPr wrap="square"/>
+                    <a:lstStyle/>
+                    <a:p>
+                      <a:r>
+                        <a:rPr sz="1150">
+                          <a:solidFill>
+                            <a:srgbClr val="E6EDF8"/>
+                          </a:solidFill>
+                          <a:latin typeface="Calibri"/>
+                        </a:rPr>
+                        <a:t>Product</a:t>
+                      </a:r>
+                    </a:p>
+                  </a:txBody>
+                  <a:tcPr marT="36576" marB="36576" marL="73152" marR="73152">
+                    <a:solidFill>
+                      <a:srgbClr val="141A2E"/>
+                    </a:solidFill>
+                  </a:tcPr>
+                </a:tc>
+                <a:tc>
+                  <a:txBody>
+                    <a:bodyPr wrap="square"/>
+                    <a:lstStyle/>
+                    <a:p>
+                      <a:r>
+                        <a:rPr sz="1150">
+                          <a:solidFill>
+                            <a:srgbClr val="E6EDF8"/>
+                          </a:solidFill>
+                          <a:latin typeface="Calibri"/>
+                        </a:rPr>
+                        <a:t>Scope · Requirements · Akzeptanzkriterien</a:t>
+                      </a:r>
+                    </a:p>
+                  </a:txBody>
+                  <a:tcPr marT="36576" marB="36576" marL="73152" marR="73152">
+                    <a:solidFill>
+                      <a:srgbClr val="141A2E"/>
+                    </a:solidFill>
+                  </a:tcPr>
+                </a:tc>
+              </a:tr>
+              <a:tr h="283464">
+                <a:tc>
+                  <a:txBody>
+                    <a:bodyPr wrap="square"/>
+                    <a:lstStyle/>
+                    <a:p>
+                      <a:r>
+                        <a:rPr sz="1150">
+                          <a:solidFill>
+                            <a:srgbClr val="E6EDF8"/>
+                          </a:solidFill>
+                          <a:latin typeface="Calibri"/>
+                        </a:rPr>
+                        <a:t>UX</a:t>
+                      </a:r>
+                    </a:p>
+                  </a:txBody>
+                  <a:tcPr marT="36576" marB="36576" marL="73152" marR="73152">
+                    <a:solidFill>
+                      <a:srgbClr val="0A0E1A"/>
+                    </a:solidFill>
+                  </a:tcPr>
+                </a:tc>
+                <a:tc>
+                  <a:txBody>
+                    <a:bodyPr wrap="square"/>
+                    <a:lstStyle/>
+                    <a:p>
+                      <a:r>
+                        <a:rPr sz="1150">
+                          <a:solidFill>
+                            <a:srgbClr val="E6EDF8"/>
+                          </a:solidFill>
+                          <a:latin typeface="Calibri"/>
+                        </a:rPr>
+                        <a:t>Flows · States · Accessibility</a:t>
+                      </a:r>
+                    </a:p>
+                  </a:txBody>
+                  <a:tcPr marT="36576" marB="36576" marL="73152" marR="73152">
+                    <a:solidFill>
+                      <a:srgbClr val="0A0E1A"/>
+                    </a:solidFill>
+                  </a:tcPr>
+                </a:tc>
+              </a:tr>
+            </a:tbl>
+          </a:graphicData>
+        </a:graphic>
+      </p:graphicFrame>
+      <p:sp>
+        <p:nvSpPr>
+          <p:cNvPr id="12" name="TextBox 11"/>
           <p:cNvSpPr txBox="1"/>
           <p:nvPr/>
         </p:nvSpPr>
         <p:spPr>
           <a:xfrm>
-            <a:off x="640080" y="3383280"/>
-            <a:ext cx="10972800" cy="3108960"/>
+            <a:off x="640080" y="5943600"/>
+            <a:ext cx="10972800" cy="640080"/>
           </a:xfrm>
           <a:prstGeom prst="rect">
             <a:avLst/>
@@ -9725,85 +10074,13 @@
           <a:p>
             <a:pPr algn="l"/>
             <a:r>
-              <a:rPr sz="1600" b="1">
-                <a:solidFill>
-                  <a:srgbClr val="22D3EE"/>
-                </a:solidFill>
-                <a:latin typeface="Calibri"/>
-              </a:rPr>
-              <a:t>TL;DR — wie der Erfinder:</a:t>
-            </a:r>
-          </a:p>
-          <a:p>
-            <a:pPr algn="l"/>
-            <a:r>
-              <a:rPr sz="1300" b="0">
-                <a:solidFill>
-                  <a:srgbClr val="E6EDF8"/>
-                </a:solidFill>
-                <a:latin typeface="Calibri"/>
-              </a:rPr>
-              <a:t>1. In Phasen: Research → /plan → /feature-dev+TDD → /code-review → Verify.</a:t>
-            </a:r>
-          </a:p>
-          <a:p>
-            <a:pPr algn="l"/>
-            <a:r>
-              <a:rPr sz="1300" b="0">
-                <a:solidFill>
-                  <a:srgbClr val="E6EDF8"/>
-                </a:solidFill>
-                <a:latin typeface="Calibri"/>
-              </a:rPr>
-              <a:t>2. Kontext sauber: &lt;10 MCPs, billigstes Modell, modulare Dateien, strategisch compacten.</a:t>
-            </a:r>
-          </a:p>
-          <a:p>
-            <a:pPr algn="l"/>
-            <a:r>
-              <a:rPr sz="1300" b="0">
-                <a:solidFill>
-                  <a:srgbClr val="E6EDF8"/>
-                </a:solidFill>
-                <a:latin typeface="Calibri"/>
-              </a:rPr>
-              <a:t>3. Persistieren: /save-session · /resume-session.</a:t>
-            </a:r>
-          </a:p>
-          <a:p>
-            <a:pPr algn="l"/>
-            <a:r>
-              <a:rPr sz="1300" b="0">
-                <a:solidFill>
-                  <a:srgbClr val="E6EDF8"/>
-                </a:solidFill>
-                <a:latin typeface="Calibri"/>
-              </a:rPr>
-              <a:t>4. Lernen: /learn-eval → /evolve → /promote.</a:t>
-            </a:r>
-          </a:p>
-          <a:p>
-            <a:pPr algn="l"/>
-            <a:r>
-              <a:rPr sz="1300" b="0">
-                <a:solidFill>
-                  <a:srgbClr val="E6EDF8"/>
-                </a:solidFill>
-                <a:latin typeface="Calibri"/>
-              </a:rPr>
-              <a:t>5. Security zuerst: RTK aktiv, Hooks/AgentShield bewusst, nie blind ausführen.</a:t>
-            </a:r>
-          </a:p>
-          <a:p>
-            <a:pPr algn="l"/>
-            <a:r>
-              <a:rPr sz="1300" b="0">
-                <a:solidFill>
-                  <a:srgbClr val="E6EDF8"/>
-                </a:solidFill>
-                <a:latin typeface="Calibri"/>
-              </a:rPr>
-              <a:t>6. Unsicher? /ecc-guide · ecc doctor · die drei Original-Guides.</a:t>
+              <a:rPr sz="1250" b="0">
+                <a:solidFill>
+                  <a:srgbClr val="8B98B0"/>
+                </a:solidFill>
+                <a:latin typeface="Calibri"/>
+              </a:rPr>
+              <a:t>Additiv — ECC-Core (ecc/) unberührt · Garantien: Marker · atomar · idempotent · selftest (7 Checks).</a:t>
             </a:r>
           </a:p>
         </p:txBody>
@@ -9943,7 +10220,7 @@
                 </a:solidFill>
                 <a:latin typeface="Calibri"/>
               </a:rPr>
-              <a:t>1 / 18</a:t>
+              <a:t>1 / 19</a:t>
             </a:r>
           </a:p>
         </p:txBody>
@@ -10260,6 +10537,403 @@
                 <a:latin typeface="Calibri"/>
               </a:rPr>
               <a:t>5 Prinzipien:  Agent-First · Test-Driven · Security-First · Immutability · Plan-Before-Execute.</a:t>
+            </a:r>
+          </a:p>
+        </p:txBody>
+      </p:sp>
+    </p:spTree>
+  </p:cSld>
+  <p:clrMapOvr>
+    <a:masterClrMapping/>
+  </p:clrMapOvr>
+</p:sld>
+</file>
+
+<file path=ppt/slides/slide20.xml><?xml version="1.0" encoding="utf-8"?>
+<p:sld xmlns:a="http://schemas.openxmlformats.org/drawingml/2006/main" xmlns:p="http://schemas.openxmlformats.org/presentationml/2006/main" xmlns:r="http://schemas.openxmlformats.org/officeDocument/2006/relationships">
+  <p:cSld>
+    <p:bg>
+      <p:bgPr>
+        <a:solidFill>
+          <a:srgbClr val="0A0E1A"/>
+        </a:solidFill>
+        <a:effectLst/>
+      </p:bgPr>
+    </p:bg>
+    <p:spTree>
+      <p:nvGrpSpPr>
+        <p:cNvPr id="1" name=""/>
+        <p:cNvGrpSpPr/>
+        <p:nvPr/>
+      </p:nvGrpSpPr>
+      <p:grpSpPr/>
+      <p:sp>
+        <p:nvSpPr>
+          <p:cNvPr id="2" name="Oval 1"/>
+          <p:cNvSpPr/>
+          <p:nvPr/>
+        </p:nvSpPr>
+        <p:spPr>
+          <a:xfrm>
+            <a:off x="548640" y="384048"/>
+            <a:ext cx="146304" cy="146304"/>
+          </a:xfrm>
+          <a:prstGeom prst="ellipse">
+            <a:avLst/>
+          </a:prstGeom>
+          <a:solidFill>
+            <a:srgbClr val="22D3EE"/>
+          </a:solidFill>
+          <a:ln>
+            <a:noFill/>
+          </a:ln>
+          <a:effectLst/>
+        </p:spPr>
+        <p:style>
+          <a:lnRef idx="1">
+            <a:schemeClr val="accent1"/>
+          </a:lnRef>
+          <a:fillRef idx="3">
+            <a:schemeClr val="accent1"/>
+          </a:fillRef>
+          <a:effectRef idx="2">
+            <a:schemeClr val="accent1"/>
+          </a:effectRef>
+          <a:fontRef idx="minor">
+            <a:schemeClr val="lt1"/>
+          </a:fontRef>
+        </p:style>
+        <p:txBody>
+          <a:bodyPr rtlCol="0" anchor="ctr"/>
+          <a:lstStyle/>
+          <a:p>
+            <a:pPr algn="ctr"/>
+          </a:p>
+        </p:txBody>
+      </p:sp>
+      <p:sp>
+        <p:nvSpPr>
+          <p:cNvPr id="3" name="TextBox 2"/>
+          <p:cNvSpPr txBox="1"/>
+          <p:nvPr/>
+        </p:nvSpPr>
+        <p:spPr>
+          <a:xfrm>
+            <a:off x="777240" y="301752"/>
+            <a:ext cx="7315200" cy="457200"/>
+          </a:xfrm>
+          <a:prstGeom prst="rect">
+            <a:avLst/>
+          </a:prstGeom>
+          <a:noFill/>
+        </p:spPr>
+        <p:txBody>
+          <a:bodyPr wrap="square">
+            <a:spAutoFit/>
+          </a:bodyPr>
+          <a:lstStyle/>
+          <a:p>
+            <a:pPr algn="l"/>
+            <a:r>
+              <a:rPr sz="1200" b="1">
+                <a:solidFill>
+                  <a:srgbClr val="22D3EE"/>
+                </a:solidFill>
+                <a:latin typeface="Calibri"/>
+              </a:rPr>
+              <a:t>QUELLEN</a:t>
+            </a:r>
+          </a:p>
+        </p:txBody>
+      </p:sp>
+      <p:sp>
+        <p:nvSpPr>
+          <p:cNvPr id="4" name="TextBox 3"/>
+          <p:cNvSpPr txBox="1"/>
+          <p:nvPr/>
+        </p:nvSpPr>
+        <p:spPr>
+          <a:xfrm>
+            <a:off x="9601200" y="301752"/>
+            <a:ext cx="2011680" cy="457200"/>
+          </a:xfrm>
+          <a:prstGeom prst="rect">
+            <a:avLst/>
+          </a:prstGeom>
+          <a:noFill/>
+        </p:spPr>
+        <p:txBody>
+          <a:bodyPr wrap="square">
+            <a:spAutoFit/>
+          </a:bodyPr>
+          <a:lstStyle/>
+          <a:p>
+            <a:pPr algn="r"/>
+            <a:r>
+              <a:rPr sz="1200" b="0">
+                <a:solidFill>
+                  <a:srgbClr val="8B98B0"/>
+                </a:solidFill>
+                <a:latin typeface="Calibri"/>
+              </a:rPr>
+              <a:t>19 / 19</a:t>
+            </a:r>
+          </a:p>
+        </p:txBody>
+      </p:sp>
+      <p:sp>
+        <p:nvSpPr>
+          <p:cNvPr id="5" name="TextBox 4"/>
+          <p:cNvSpPr txBox="1"/>
+          <p:nvPr/>
+        </p:nvSpPr>
+        <p:spPr>
+          <a:xfrm>
+            <a:off x="548640" y="777240"/>
+            <a:ext cx="11064240" cy="777240"/>
+          </a:xfrm>
+          <a:prstGeom prst="rect">
+            <a:avLst/>
+          </a:prstGeom>
+          <a:noFill/>
+        </p:spPr>
+        <p:txBody>
+          <a:bodyPr wrap="square">
+            <a:spAutoFit/>
+          </a:bodyPr>
+          <a:lstStyle/>
+          <a:p>
+            <a:pPr algn="l"/>
+            <a:r>
+              <a:rPr sz="2700" b="1">
+                <a:solidFill>
+                  <a:srgbClr val="E6EDF8"/>
+                </a:solidFill>
+                <a:latin typeface="Calibri"/>
+              </a:rPr>
+              <a:t>Quellen &amp; TL;DR</a:t>
+            </a:r>
+          </a:p>
+        </p:txBody>
+      </p:sp>
+      <p:sp>
+        <p:nvSpPr>
+          <p:cNvPr id="6" name="Rectangle 5"/>
+          <p:cNvSpPr/>
+          <p:nvPr/>
+        </p:nvSpPr>
+        <p:spPr>
+          <a:xfrm>
+            <a:off x="594360" y="1481328"/>
+            <a:ext cx="2011680" cy="41148"/>
+          </a:xfrm>
+          <a:prstGeom prst="rect">
+            <a:avLst/>
+          </a:prstGeom>
+          <a:solidFill>
+            <a:srgbClr val="22D3EE"/>
+          </a:solidFill>
+          <a:ln>
+            <a:noFill/>
+          </a:ln>
+          <a:effectLst/>
+        </p:spPr>
+        <p:style>
+          <a:lnRef idx="1">
+            <a:schemeClr val="accent1"/>
+          </a:lnRef>
+          <a:fillRef idx="3">
+            <a:schemeClr val="accent1"/>
+          </a:fillRef>
+          <a:effectRef idx="2">
+            <a:schemeClr val="accent1"/>
+          </a:effectRef>
+          <a:fontRef idx="minor">
+            <a:schemeClr val="lt1"/>
+          </a:fontRef>
+        </p:style>
+        <p:txBody>
+          <a:bodyPr rtlCol="0" anchor="ctr"/>
+          <a:lstStyle/>
+          <a:p>
+            <a:pPr algn="ctr"/>
+          </a:p>
+        </p:txBody>
+      </p:sp>
+      <p:sp>
+        <p:nvSpPr>
+          <p:cNvPr id="7" name="TextBox 6"/>
+          <p:cNvSpPr txBox="1"/>
+          <p:nvPr/>
+        </p:nvSpPr>
+        <p:spPr>
+          <a:xfrm>
+            <a:off x="640080" y="1737360"/>
+            <a:ext cx="10972800" cy="1554480"/>
+          </a:xfrm>
+          <a:prstGeom prst="rect">
+            <a:avLst/>
+          </a:prstGeom>
+          <a:noFill/>
+        </p:spPr>
+        <p:txBody>
+          <a:bodyPr wrap="none">
+            <a:spAutoFit/>
+          </a:bodyPr>
+          <a:lstStyle/>
+          <a:p>
+            <a:pPr algn="l"/>
+            <a:r>
+              <a:rPr sz="1400" b="1">
+                <a:solidFill>
+                  <a:srgbClr val="22D3EE"/>
+                </a:solidFill>
+                <a:latin typeface="Calibri"/>
+              </a:rPr>
+              <a:t>Guides von @affaanmustafa (X-Threads; lokal unter ecc/):</a:t>
+            </a:r>
+          </a:p>
+          <a:p>
+            <a:pPr algn="l"/>
+            <a:r>
+              <a:rPr sz="1150" b="0">
+                <a:solidFill>
+                  <a:srgbClr val="E6EDF8"/>
+                </a:solidFill>
+                <a:latin typeface="Calibri"/>
+              </a:rPr>
+              <a:t>Shortform: https://x.com/affaanmustafa/status/2012378465664745795</a:t>
+            </a:r>
+          </a:p>
+          <a:p>
+            <a:pPr algn="l"/>
+            <a:r>
+              <a:rPr sz="1150" b="0">
+                <a:solidFill>
+                  <a:srgbClr val="E6EDF8"/>
+                </a:solidFill>
+                <a:latin typeface="Calibri"/>
+              </a:rPr>
+              <a:t>Longform:  https://x.com/affaanmustafa/status/2014040193557471352</a:t>
+            </a:r>
+          </a:p>
+          <a:p>
+            <a:pPr algn="l"/>
+            <a:r>
+              <a:rPr sz="1150" b="0">
+                <a:solidFill>
+                  <a:srgbClr val="E6EDF8"/>
+                </a:solidFill>
+                <a:latin typeface="Calibri"/>
+              </a:rPr>
+              <a:t>Security:  https://x.com/affaanmustafa/status/2033263813387223421</a:t>
+            </a:r>
+          </a:p>
+        </p:txBody>
+      </p:sp>
+      <p:sp>
+        <p:nvSpPr>
+          <p:cNvPr id="8" name="TextBox 7"/>
+          <p:cNvSpPr txBox="1"/>
+          <p:nvPr/>
+        </p:nvSpPr>
+        <p:spPr>
+          <a:xfrm>
+            <a:off x="640080" y="3383280"/>
+            <a:ext cx="10972800" cy="3108960"/>
+          </a:xfrm>
+          <a:prstGeom prst="rect">
+            <a:avLst/>
+          </a:prstGeom>
+          <a:noFill/>
+        </p:spPr>
+        <p:txBody>
+          <a:bodyPr wrap="none">
+            <a:spAutoFit/>
+          </a:bodyPr>
+          <a:lstStyle/>
+          <a:p>
+            <a:pPr algn="l"/>
+            <a:r>
+              <a:rPr sz="1600" b="1">
+                <a:solidFill>
+                  <a:srgbClr val="22D3EE"/>
+                </a:solidFill>
+                <a:latin typeface="Calibri"/>
+              </a:rPr>
+              <a:t>TL;DR — wie der Erfinder:</a:t>
+            </a:r>
+          </a:p>
+          <a:p>
+            <a:pPr algn="l"/>
+            <a:r>
+              <a:rPr sz="1300" b="0">
+                <a:solidFill>
+                  <a:srgbClr val="E6EDF8"/>
+                </a:solidFill>
+                <a:latin typeface="Calibri"/>
+              </a:rPr>
+              <a:t>1. In Phasen: Research → /plan → /feature-dev+TDD → /code-review → Verify.</a:t>
+            </a:r>
+          </a:p>
+          <a:p>
+            <a:pPr algn="l"/>
+            <a:r>
+              <a:rPr sz="1300" b="0">
+                <a:solidFill>
+                  <a:srgbClr val="E6EDF8"/>
+                </a:solidFill>
+                <a:latin typeface="Calibri"/>
+              </a:rPr>
+              <a:t>2. Kontext sauber: &lt;10 MCPs, billigstes Modell, modulare Dateien, strategisch compacten.</a:t>
+            </a:r>
+          </a:p>
+          <a:p>
+            <a:pPr algn="l"/>
+            <a:r>
+              <a:rPr sz="1300" b="0">
+                <a:solidFill>
+                  <a:srgbClr val="E6EDF8"/>
+                </a:solidFill>
+                <a:latin typeface="Calibri"/>
+              </a:rPr>
+              <a:t>3. Persistieren: /save-session · /resume-session.</a:t>
+            </a:r>
+          </a:p>
+          <a:p>
+            <a:pPr algn="l"/>
+            <a:r>
+              <a:rPr sz="1300" b="0">
+                <a:solidFill>
+                  <a:srgbClr val="E6EDF8"/>
+                </a:solidFill>
+                <a:latin typeface="Calibri"/>
+              </a:rPr>
+              <a:t>4. Lernen: /learn-eval → /evolve → /promote.</a:t>
+            </a:r>
+          </a:p>
+          <a:p>
+            <a:pPr algn="l"/>
+            <a:r>
+              <a:rPr sz="1300" b="0">
+                <a:solidFill>
+                  <a:srgbClr val="E6EDF8"/>
+                </a:solidFill>
+                <a:latin typeface="Calibri"/>
+              </a:rPr>
+              <a:t>5. Security zuerst: RTK aktiv, Hooks/AgentShield bewusst, nie blind ausführen.</a:t>
+            </a:r>
+          </a:p>
+          <a:p>
+            <a:pPr algn="l"/>
+            <a:r>
+              <a:rPr sz="1300" b="0">
+                <a:solidFill>
+                  <a:srgbClr val="E6EDF8"/>
+                </a:solidFill>
+                <a:latin typeface="Calibri"/>
+              </a:rPr>
+              <a:t>6. Unsicher? /ecc-guide · ecc doctor · die drei Original-Guides.</a:t>
             </a:r>
           </a:p>
         </p:txBody>
@@ -10399,7 +11073,7 @@
                 </a:solidFill>
                 <a:latin typeface="Calibri"/>
               </a:rPr>
-              <a:t>2 / 18</a:t>
+              <a:t>2 / 19</a:t>
             </a:r>
           </a:p>
         </p:txBody>
@@ -11044,7 +11718,7 @@
                 </a:solidFill>
                 <a:latin typeface="Calibri"/>
               </a:rPr>
-              <a:t>3 / 18</a:t>
+              <a:t>3 / 19</a:t>
             </a:r>
           </a:p>
         </p:txBody>
@@ -12033,7 +12707,7 @@
                 </a:solidFill>
                 <a:latin typeface="Calibri"/>
               </a:rPr>
-              <a:t>4 / 18</a:t>
+              <a:t>4 / 19</a:t>
             </a:r>
           </a:p>
         </p:txBody>
@@ -12659,7 +13333,7 @@
                 </a:solidFill>
                 <a:latin typeface="Calibri"/>
               </a:rPr>
-              <a:t>5 / 18</a:t>
+              <a:t>5 / 19</a:t>
             </a:r>
           </a:p>
         </p:txBody>
@@ -13708,7 +14382,7 @@
                 </a:solidFill>
                 <a:latin typeface="Calibri"/>
               </a:rPr>
-              <a:t>6 / 18</a:t>
+              <a:t>6 / 19</a:t>
             </a:r>
           </a:p>
         </p:txBody>
@@ -14569,7 +15243,7 @@
                 </a:solidFill>
                 <a:latin typeface="Calibri"/>
               </a:rPr>
-              <a:t>7 / 18</a:t>
+              <a:t>7 / 19</a:t>
             </a:r>
           </a:p>
         </p:txBody>
@@ -15172,7 +15846,7 @@
                 </a:solidFill>
                 <a:latin typeface="Calibri"/>
               </a:rPr>
-              <a:t>8 / 18</a:t>
+              <a:t>8 / 19</a:t>
             </a:r>
           </a:p>
         </p:txBody>

</xml_diff>

<commit_message>
feat(harness): Schicht-2 scharf — State-Sync aktiv, ecc-onboard-Drift behoben, Extras deployed
- Schritt 0: globale ecc-onboard.md auf 13K-Version (State-Sync-Verdrahtung + consumer-scaffold)
- install-vps.sh additiv erweitert: rpi-Advisors, attribution-policy, start.md (-ef-Guard), contexts/
- State-Sync projekt-lokal verdrahtet (Variante A): .claude/settings.json SessionStart/Stop/PreCompact
- Repo onboardet: state/ befuellt + harvest, WORKING-CONTEXT.md generiert
- contexts/{dev,review}.md angelegt (Dynamic-Context-Profile)
- Guides aktualisiert: ECC-ERKLAERBUCH Abschnitt 15, CLAUDE.md Hooks-Liste, docx/pptx Status nachgezogen
- ECC-Core unberuehrt (git status -- ecc/ leer), RTK-Hook intakt

Co-Authored-By: Claude Opus 4.8 (1M context) <noreply@anthropic.com>
</commit_message>
<xml_diff>
--- a/docs/ECC-Harness-Guide.de.pptx
+++ b/docs/ECC-Harness-Guide.de.pptx
@@ -25,6 +25,7 @@
     <p:sldId id="273" r:id="rId24"/>
     <p:sldId id="274" r:id="rId25"/>
     <p:sldId id="275" r:id="rId26"/>
+    <p:sldId id="276" r:id="rId27"/>
   </p:sldIdLst>
   <p:sldSz cx="12191695" cy="6858000" type="screen4x3"/>
   <p:notesSz cx="6858000" cy="9144000"/>
@@ -10946,6 +10947,81 @@
 </p:sld>
 </file>
 
+<file path=ppt/slides/slide21.xml><?xml version="1.0" encoding="utf-8"?>
+<p:sld xmlns:a="http://schemas.openxmlformats.org/drawingml/2006/main" xmlns:p="http://schemas.openxmlformats.org/presentationml/2006/main" xmlns:r="http://schemas.openxmlformats.org/officeDocument/2006/relationships">
+  <p:cSld>
+    <p:spTree>
+      <p:nvGrpSpPr>
+        <p:cNvPr id="1" name=""/>
+        <p:cNvGrpSpPr/>
+        <p:nvPr/>
+      </p:nvGrpSpPr>
+      <p:grpSpPr/>
+      <p:sp>
+        <p:nvSpPr>
+          <p:cNvPr id="2" name="Title 1"/>
+          <p:cNvSpPr>
+            <a:spLocks noGrp="1"/>
+          </p:cNvSpPr>
+          <p:nvPr>
+            <p:ph type="title"/>
+          </p:nvPr>
+        </p:nvSpPr>
+        <p:spPr/>
+        <p:txBody>
+          <a:bodyPr/>
+          <a:lstStyle/>
+          <a:p>
+            <a:r>
+              <a:t>15. Aktivierungs-Status (Stand 2026-06-05)</a:t>
+            </a:r>
+          </a:p>
+        </p:txBody>
+      </p:sp>
+      <p:sp>
+        <p:nvSpPr>
+          <p:cNvPr id="3" name="Content Placeholder 2"/>
+          <p:cNvSpPr>
+            <a:spLocks noGrp="1"/>
+          </p:cNvSpPr>
+          <p:nvPr>
+            <p:ph idx="1"/>
+          </p:nvPr>
+        </p:nvSpPr>
+        <p:spPr/>
+        <p:txBody>
+          <a:bodyPr wrap="square"/>
+          <a:lstStyle/>
+          <a:p>
+            <a:r>
+              <a:t>State-Sync aktiv (Variante A, projekt-lokal): SessionStart-&gt;pre, Stop/PreCompact-&gt;post; WORKING-CONTEXT.md wird aus state/ gespiegelt; ecc/-Guard unberuehrt.</a:t>
+            </a:r>
+          </a:p>
+          <a:p>
+            <a:r>
+              <a:t>Globale ecc-onboard.md-Drift behoben (6,3K -&gt; 13K, mit State-Sync-Verdrahtung + consumer-scaffold).</a:t>
+            </a:r>
+          </a:p>
+          <a:p>
+            <a:r>
+              <a:t>Extras global gelayert: rpi-Advisors, attribution-policy.md, contexts/dev+review; install-vps.sh deployt das kuenftig automatisch.</a:t>
+            </a:r>
+          </a:p>
+          <a:p>
+            <a:r>
+              <a:t>Unberuehrt: ECC-Core (git status -- ecc/ leer), RTK-Hook (PreToolUse:Bash), globale ECC-Lifecycle-Hooks.</a:t>
+            </a:r>
+          </a:p>
+        </p:txBody>
+      </p:sp>
+    </p:spTree>
+  </p:cSld>
+  <p:clrMapOvr>
+    <a:masterClrMapping/>
+  </p:clrMapOvr>
+</p:sld>
+</file>
+
 <file path=ppt/slides/slide3.xml><?xml version="1.0" encoding="utf-8"?>
 <p:sld xmlns:a="http://schemas.openxmlformats.org/drawingml/2006/main" xmlns:p="http://schemas.openxmlformats.org/presentationml/2006/main" xmlns:r="http://schemas.openxmlformats.org/officeDocument/2006/relationships">
   <p:cSld>

</xml_diff>

<commit_message>
chore(harness): Arbeitsstand der letzten Tage sichern
Onboard-Skripte (onboard.js/onboard-verify.js), state-sync + Doku
(Erklärbuch, Harness-Guide docx/pptx/md, WO-LAEUFT-WAS), PROJECT_RULES,
ecc-onboard-Command und State-Sync-Hook-Cleanup in settings.json.

Co-Authored-By: Claude Opus 4.8 (1M context) <noreply@anthropic.com>
</commit_message>
<xml_diff>
--- a/docs/ECC-Harness-Guide.de.pptx
+++ b/docs/ECC-Harness-Guide.de.pptx
@@ -3285,7 +3285,7 @@
               </a:defRPr>
             </a:pPr>
             <a:r>
-              <a:t>Global aktiv in ~/.claude · ECC 2.0.0-rc.1 (core, führend) · RTK-sicher.</a:t>
+              <a:t>ECC 2.0.0-rc.1 als globales Plugin ecc@ecc (führend) · Schicht-2-Extras im Repo · RTK-sicher.</a:t>
             </a:r>
           </a:p>
           <a:p>
@@ -3300,7 +3300,7 @@
               </a:defRPr>
             </a:pPr>
             <a:r>
-              <a:t>Quelle/Re-Install: /root/projekte/Claude Code BestPractice → ./install-vps.sh</a:t>
+              <a:t>Seit der Plugin-only-Migration (2026-06-10): keine vendored ecc/-Kopie mehr, claude-mem/superpowers deaktiviert.</a:t>
             </a:r>
           </a:p>
           <a:p>
@@ -3330,7 +3330,7 @@
               </a:defRPr>
             </a:pPr>
             <a:r>
-              <a:t>Single Source ist diese Markdown-Datei (docs/ECC-Harness-Guide.de.md). Die Word-/PowerPoint-Snapshots werden daraus gebaut: bestpractice-extras/scripts/build-docs/. Stand: 2026-06-05.</a:t>
+              <a:t>Single Source ist diese Markdown-Datei (docs/ECC-Harness-Guide.de.md). Die Word-/PowerPoint-Snapshots werden daraus gebaut: bestpractice-extras/scripts/build-docs/. Stand: 2026-06-10.</a:t>
             </a:r>
           </a:p>
         </p:txBody>
@@ -3503,7 +3503,7 @@
             </a:pPr>
             <a:r>
               <a:rPr sz="1100" b="0"/>
-              <a:t>1 · RESEARCH — Explore-Agent: Routing/Handler/Tests kartieren (+ claude-mem) — Haiku — research.md</a:t>
+              <a:t>1 · RESEARCH — Explore-Agent: Routing/Handler/Tests kartieren (+ memory-MCP) — Haiku — research.md</a:t>
             </a:r>
           </a:p>
           <a:p>
@@ -4007,7 +4007,7 @@
             </a:pPr>
             <a:r>
               <a:rPr sz="1500" b="0"/>
-              <a:t>Session-Start — /start · claude-mem injiziert Kontext (ab 2. Session) · rtk gain — nahtlos weiter, wo du warst</a:t>
+              <a:t>Session-Start — /start (State-Sync PRE + rtk-Budget + Agenda) — nahtlos weiter, wo du warst</a:t>
             </a:r>
           </a:p>
           <a:p>
@@ -4018,7 +4018,7 @@
             </a:pPr>
             <a:r>
               <a:rPr sz="1500" b="0"/>
-              <a:t>Vor großer Aufgabe — /resume-session · /mem-search „schon gelöst?" — Alt-Wissen nutzen statt neu lösen</a:t>
+              <a:t>Vor großer Aufgabe — /resume-session · memory-MCP search_nodes „schon gelöst?" · /instinct-status — Alt-Wissen nutzen statt neu lösen</a:t>
             </a:r>
           </a:p>
           <a:p>
@@ -4246,7 +4246,7 @@
             </a:pPr>
             <a:r>
               <a:rPr sz="1100" b="0"/>
-              <a:t>Bug — /systematic-debugging — Root-Cause vor Fix</a:t>
+              <a:t>Bug — reproduzieren + failing Test (ecc:tdd-workflow) — Root-Cause vor Fix, nie blind fixen</a:t>
             </a:r>
           </a:p>
           <a:p>
@@ -4257,7 +4257,7 @@
             </a:pPr>
             <a:r>
               <a:rPr sz="1100" b="0"/>
-              <a:t>Projekt ECC-ready machen — /ecc-onboard — Stack erkennen → 1× OK → Rules/Skills + PROJECT_RULES.md + state/</a:t>
+              <a:t>Projekt ECC-ready machen — /ecc-onboard — Dry-Run → 1× OK → De-Cruft + Slim-Scaffold (env + state/ + PROJECT_RULES.md) + Abnahme</a:t>
             </a:r>
           </a:p>
           <a:p>
@@ -4636,7 +4636,7 @@
             </a:pPr>
             <a:r>
               <a:rPr sz="1200" b="0"/>
-              <a:t>Faustregel: 20–30 MCPs konfiguriert, aber &lt; 10 aktiv / &lt; 80 Tools. Ungenutztes pro Projekt mit /mcp deaktivieren — das Kontextfenster ist kostbar.</a:t>
+              <a:t>Faustregel: &lt; 10 MCPs aktiv / &lt; 80 Tools. Ungenutztes pro Projekt mit /mcp deaktivieren — das Kontextfenster ist kostbar.</a:t>
             </a:r>
           </a:p>
           <a:p>
@@ -4647,7 +4647,95 @@
             </a:pPr>
             <a:r>
               <a:rPr sz="1200" b="0"/>
-              <a:t>Bei dir aktiv (global):</a:t>
+              <a:t>Das ECC-Plugin bringt 6 MCP-Server mit (automatisch verfügbar, nichts zu konfigurieren):</a:t>
+            </a:r>
+          </a:p>
+          <a:p>
+            <a:pPr>
+              <a:spcAft>
+                <a:spcPts val="300"/>
+              </a:spcAft>
+            </a:pPr>
+            <a:r>
+              <a:rPr sz="1200" b="1"/>
+              <a:t>Aufgabe · MCP (via ECC) · Hinweis</a:t>
+            </a:r>
+          </a:p>
+          <a:p>
+            <a:pPr lvl="1">
+              <a:spcAft>
+                <a:spcPts val="300"/>
+              </a:spcAft>
+            </a:pPr>
+            <a:r>
+              <a:rPr sz="1100" b="0"/>
+              <a:t>Frühere Arbeit / Wissensgraph — memory — search_nodes / open_nodes / create_entities — deine primäre Memory-Quelle (§11)</a:t>
+            </a:r>
+          </a:p>
+          <a:p>
+            <a:pPr lvl="1">
+              <a:spcAft>
+                <a:spcPts val="300"/>
+              </a:spcAft>
+            </a:pPr>
+            <a:r>
+              <a:rPr sz="1100" b="0"/>
+              <a:t>Aktuelle Library-/API-Doku — context7 — React, Prisma, Next.js … statt veraltetem Wissen. Läuft über ECC (`mcp__plugin_ecc_context7__*`) — das offizielle context7-Plugin bleibt bewusst aus (keine Dubletten)</a:t>
+            </a:r>
+          </a:p>
+          <a:p>
+            <a:pPr lvl="1">
+              <a:spcAft>
+                <a:spcPts val="300"/>
+              </a:spcAft>
+            </a:pPr>
+            <a:r>
+              <a:rPr sz="1100" b="0"/>
+              <a:t>GitHub (PRs, Issues, Code-Suche) — github — ergänzt die gh-CLI</a:t>
+            </a:r>
+          </a:p>
+          <a:p>
+            <a:pPr lvl="1">
+              <a:spcAft>
+                <a:spcPts val="300"/>
+              </a:spcAft>
+            </a:pPr>
+            <a:r>
+              <a:rPr sz="1100" b="0"/>
+              <a:t>Web-Recherche / Discovery — exa — breite Suche, wenn GitHub+Docs nicht reichen</a:t>
+            </a:r>
+          </a:p>
+          <a:p>
+            <a:pPr lvl="1">
+              <a:spcAft>
+                <a:spcPts val="300"/>
+              </a:spcAft>
+            </a:pPr>
+            <a:r>
+              <a:rPr sz="1100" b="0"/>
+              <a:t>Browser / E2E / Screenshots — playwright — headless Automation, visuelle Tests</a:t>
+            </a:r>
+          </a:p>
+          <a:p>
+            <a:pPr lvl="1">
+              <a:spcAft>
+                <a:spcPts val="300"/>
+              </a:spcAft>
+            </a:pPr>
+            <a:r>
+              <a:rPr sz="1100" b="0"/>
+              <a:t>Schrittweises Reasoning — sequential-thinking — komplexe Mehrschritt-Probleme (s. §15)</a:t>
+            </a:r>
+          </a:p>
+          <a:p>
+            <a:pPr>
+              <a:spcAft>
+                <a:spcPts val="300"/>
+              </a:spcAft>
+            </a:pPr>
+            <a:r>
+              <a:rPr sz="1200" b="0"/>
+              <a:t>Dazu unabhängig von ECC:</a:t>
             </a:r>
           </a:p>
           <a:p>
@@ -4669,7 +4757,7 @@
             </a:pPr>
             <a:r>
               <a:rPr sz="1100" b="0"/>
-              <a:t>PDF/Word/Excel/PPTX lesen — markitdown — Dokumente → Markdown (lokal, global aktiv)</a:t>
+              <a:t>PDF/Word/Excel/PPTX lesen — markitdown — Dokumente → Markdown (lokal)</a:t>
             </a:r>
           </a:p>
           <a:p>
@@ -4680,95 +4768,7 @@
             </a:pPr>
             <a:r>
               <a:rPr sz="1100" b="0"/>
-              <a:t>Aktuelle Library-/API-Doku — context7 — React, Prisma, Next.js … statt veraltetem Wissen (Plugin)</a:t>
-            </a:r>
-          </a:p>
-          <a:p>
-            <a:pPr lvl="1">
-              <a:spcAft>
-                <a:spcPts val="300"/>
-              </a:spcAft>
-            </a:pPr>
-            <a:r>
-              <a:rPr sz="1100" b="0"/>
-              <a:t>Frühere Arbeit / „schon gelöst?" — claude-mem — deine Memory-Quelle: /mem-search, Auto-Injektion ab 2. Session</a:t>
-            </a:r>
-          </a:p>
-          <a:p>
-            <a:pPr lvl="1">
-              <a:spcAft>
-                <a:spcPts val="300"/>
-              </a:spcAft>
-            </a:pPr>
-            <a:r>
-              <a:rPr sz="1100" b="0"/>
-              <a:t>Dienste anbinden — claude.ai-Connectoren — n8n · Notion · Gamma · Google Drive · Microsoft Learn · Kiwi</a:t>
-            </a:r>
-          </a:p>
-          <a:p>
-            <a:pPr lvl="1">
-              <a:spcAft>
-                <a:spcPts val="300"/>
-              </a:spcAft>
-            </a:pPr>
-            <a:r>
-              <a:rPr sz="1100" b="0"/>
-              <a:t>Bash-Token sparen — RTK (Hook, kein MCP) — 60–90 % Ersparnis, läuft transparent global</a:t>
-            </a:r>
-          </a:p>
-          <a:p>
-            <a:pPr lvl="1">
-              <a:spcAft>
-                <a:spcPts val="300"/>
-              </a:spcAft>
-            </a:pPr>
-            <a:r>
-              <a:rPr sz="1100" b="0"/>
-              <a:t>Semantische Code-/Doku-Suche — mgrep (CLI/Skill, kein MCP) — ~50 % weniger Token als grep — Details in §15</a:t>
-            </a:r>
-          </a:p>
-          <a:p>
-            <a:pPr>
-              <a:spcAft>
-                <a:spcPts val="300"/>
-              </a:spcAft>
-            </a:pPr>
-            <a:r>
-              <a:rPr sz="1200" b="0"/>
-              <a:t>Optional / empfohlen — NICHT installiert, bei Bedarf nachrüsten:</a:t>
-            </a:r>
-          </a:p>
-          <a:p>
-            <a:pPr>
-              <a:spcAft>
-                <a:spcPts val="300"/>
-              </a:spcAft>
-            </a:pPr>
-            <a:r>
-              <a:rPr sz="1200" b="1"/>
-              <a:t>Aufgabe · MCP / Tool · Hinweis</a:t>
-            </a:r>
-          </a:p>
-          <a:p>
-            <a:pPr lvl="1">
-              <a:spcAft>
-                <a:spcPts val="300"/>
-              </a:spcAft>
-            </a:pPr>
-            <a:r>
-              <a:rPr sz="1100" b="0"/>
-              <a:t>Web-Recherche / Discovery — exa — breite Suche, wenn GitHub+Docs nicht reichen</a:t>
-            </a:r>
-          </a:p>
-          <a:p>
-            <a:pPr lvl="1">
-              <a:spcAft>
-                <a:spcPts val="300"/>
-              </a:spcAft>
-            </a:pPr>
-            <a:r>
-              <a:rPr sz="1100" b="0"/>
-              <a:t>GitHub (PRs, Issues, Code-Suche) — github — du nutzt die gh-CLI statt MCP</a:t>
+              <a:t>Dienste anbinden — claude.ai-Connectoren — n8n · Notion · Gamma · Google Drive · Microsoft Learn …</a:t>
             </a:r>
           </a:p>
         </p:txBody>
@@ -4897,7 +4897,7 @@
             </a:pPr>
             <a:r>
               <a:rPr sz="1500" b="0"/>
-              <a:t>Browser / E2E / Screenshots — playwright — headless Automation, visuelle Tests</a:t>
+              <a:t>Bash-Token sparen — RTK (Hook, kein MCP) — 60–90 % Ersparnis, läuft transparent global</a:t>
             </a:r>
           </a:p>
           <a:p>
@@ -4908,18 +4908,7 @@
             </a:pPr>
             <a:r>
               <a:rPr sz="1500" b="0"/>
-              <a:t>Strukturierter Wissensgraph — memory — NICHT nötig, claude-mem deckt das ab</a:t>
-            </a:r>
-          </a:p>
-          <a:p>
-            <a:pPr lvl="1">
-              <a:spcAft>
-                <a:spcPts val="300"/>
-              </a:spcAft>
-            </a:pPr>
-            <a:r>
-              <a:rPr sz="1500" b="0"/>
-              <a:t>Schrittweises Reasoning — sequential-thinking — komplexe Mehrschritt-Probleme (s. §15)</a:t>
+              <a:t>Semantische Code-/Doku-Suche — mgrep (CLI/Skill, kein MCP) — ~50 % weniger Token als grep — Details in §15</a:t>
             </a:r>
           </a:p>
           <a:p>
@@ -4930,7 +4919,7 @@
             </a:pPr>
             <a:r>
               <a:rPr sz="1600" b="0"/>
-              <a:t>Memory-Klarstellung: Der „memory"-MCP (Wissensgraph) ist NICHT installiert und nicht nötig — claude-mem ist deine primäre Memory-Quelle (§11). EINE Quelle pro Projekt, sonst doppelte Wahrheit.</a:t>
+              <a:t>Memory-Klarstellung (seit 2026-06-10 umgedreht): Der memory-MCP (Wissensgraph) IST installiert (via ECC) und ist deine primäre Memory-Quelle; claude-mem ist deaktiviert. EINE Quelle pro Projekt, sonst doppelte Wahrheit. ⚠️ Die Graph-Datei liegt im npx-Cache (~/.npm/_npx/&lt;hash&gt;/…/memory.jsonl, kein MEMORY_FILE_PATH gesetzt) — kompakte Schlüssel-Fakten dort, langlebige Wahrheit zusätzlich in state//Doku (Git).</a:t>
             </a:r>
           </a:p>
         </p:txBody>
@@ -5147,7 +5136,7 @@
             </a:pPr>
             <a:r>
               <a:rPr sz="1200" b="0"/>
-              <a:t>Agenten-Zuweisungen (Default): security-reviewer → Opus (darf nichts übersehen) · architect, planner → Opus · code-reviewer, tdd-guide, build-error-resolver → Sonnet · doc-updater, code-tour → Haiku.</a:t>
+              <a:t>Agenten-Zuweisungen (automatisch!): Jeder ECC-Agent trägt sein Modell als model:-Frontmatter in seiner Definition — du wählst nichts: planner, architect → Opus · Reviewer, Build-Resolver, tdd-guide, security-reviewer u. a. → Sonnet · doc-updater → Haiku. Das gilt unabhängig vom Modell deiner Haupt-Session; manuell überschreiben nur bewusst (Agent-Tool-Parameter model).</a:t>
             </a:r>
           </a:p>
           <a:p>
@@ -5320,7 +5309,7 @@
             </a:pPr>
             <a:r>
               <a:rPr sz="1200" b="0"/>
-              <a:t>claude-mem ist deine primäre, persistente Memory-Quelle:</a:t>
+              <a:t>Drei Gedächtnisse, drei Aufgaben (claude-mem ist deaktiviert):</a:t>
             </a:r>
           </a:p>
           <a:p>
@@ -5331,7 +5320,7 @@
             </a:pPr>
             <a:r>
               <a:rPr sz="1200" b="0"/>
-              <a:t>• Automatisch: injiziert relevanten Kontext aus früheren Sessions ab der 2. Session je Projekt — ohne Zutun.</a:t>
+              <a:t>• memory-MCP (Wissensgraph, via ECC): Fakten als Entities/Relations/Observations. Aktiv nutzen: search_nodes („schon gelöst?"), open_nodes, create_entities/add_observations („Merke dir: …") — Claude speichert nicht alles von selbst, wichtige Entscheidungen explizit merken lassen.</a:t>
             </a:r>
           </a:p>
           <a:p>
@@ -5342,7 +5331,7 @@
             </a:pPr>
             <a:r>
               <a:rPr sz="1200" b="0"/>
-              <a:t>• /mem-search „…": gezielt frühere Arbeit finden („schon gelöst?", „wie haben wir X gemacht?").</a:t>
+              <a:t>• Instincts (Continuous Learning): ECC sammelt Arbeitsmuster automatisch (observe-Hooks, Profil standard); einsehen mit /instinct-status, befördern mit /promote.</a:t>
             </a:r>
           </a:p>
           <a:p>
@@ -5353,7 +5342,7 @@
             </a:pPr>
             <a:r>
               <a:rPr sz="1200" b="0"/>
-              <a:t>• Erfasst von selbst: Beobachtungen/Entscheidungen werden automatisch gespeichert — kein manuelles Speichern.</a:t>
+              <a:t>• state/ + WORKING-CONTEXT.md (State-Sync, Schicht 2): Projekt-Zustand, automatisch via SessionStart/Stop-Hooks in onboardeten Projekten; von Hand pflegst du state/.md.</a:t>
             </a:r>
           </a:p>
           <a:p>
@@ -5441,7 +5430,7 @@
             </a:pPr>
             <a:r>
               <a:rPr sz="1200" b="0"/>
-              <a:t>Gute Session-Datei: Was funktioniert hat (mit Evidenz) · Was nicht ging · Was offen ist. EINE Memory-Quelle: claude-mem ist gesetzt — den generischen „memory"-MCP NICHT zusätzlich aktivieren. Keine Secrets in Memory.</a:t>
+              <a:t>Gute Session-Datei: Was funktioniert hat (mit Evidenz) · Was nicht ging · Was offen ist. EINE Memory-Quelle je Zweck: memory-MCP für Fakten, Instincts für Muster, state/ für Projekt-Zustand — claude-mem bleibt aus. Keine Secrets in Memory.</a:t>
             </a:r>
           </a:p>
         </p:txBody>
@@ -5798,7 +5787,7 @@
             </a:pPr>
             <a:r>
               <a:rPr sz="1600" b="0"/>
-              <a:t>• ECC (Everything Claude Code) von Affaan Mustafa — die dominante Engine: 63 Agents, 249 Skills, ~80 Commands, manifest-basierter Installer, Continuous Learning, Security-Scanning. Global installiert (core-Profil): 80 Commands, 63 Agents, 21 ECC-Skills, rules/ecc = common + 19 Sprach-/Domain-Packs; mehr Skills via --profile full (249).</a:t>
+              <a:t>• ECC (Everything Claude Code) von Affaan Mustafa — die dominante Engine: 63 Agents, 249 Skills, ~80 Commands, Continuous Learning, Security-Scanning, 6 mitgebrachte MCP-Server. Läuft als globales Plugin ecc@ecc, gepinnt auf Upstream-Tag v2.0.0-rc.1 (Cache: ~/.claude/plugins/cache/ecc/ecc/2.0.0-rc.1/) — damit in JEDEM Projekt verfügbar, ohne Kopien im Home oder Repo.</a:t>
             </a:r>
           </a:p>
           <a:p>
@@ -6148,7 +6137,51 @@
             </a:pPr>
             <a:r>
               <a:rPr sz="1200" b="0"/>
-              <a:t>Hooks sind kleine Programme, die von selbst an Lifecycle-Events feuern (vorher prüfen/blockieren, nachher aufräumen/formatieren/protokollieren). Wichtig zu wissen: Die ECC-hooks.json enthält 20+ Hooks, aber das ECC-plugin.json registriert keine Hooks automatisch — sie wurden gezielt in ~/.claude/settings.json aktiviert.</a:t>
+              <a:t>Hooks sind kleine Programme, die von selbst an Lifecycle-Events feuern (vorher prüfen/blockieren, nachher aufräumen/formatieren/protokollieren). Seit der Plugin-Migration registriert das Plugin selbst seine Hooks (hooks/hooks.json, 20+ Stück); welche tatsächlich feuern, steuert das Profil ECC_HOOK_PROFILE pro Scope:</a:t>
+            </a:r>
+          </a:p>
+          <a:p>
+            <a:pPr>
+              <a:spcAft>
+                <a:spcPts val="300"/>
+              </a:spcAft>
+            </a:pPr>
+            <a:r>
+              <a:rPr sz="1200" b="1"/>
+              <a:t>Scope · Profil · Effekt</a:t>
+            </a:r>
+          </a:p>
+          <a:p>
+            <a:pPr lvl="1">
+              <a:spcAft>
+                <a:spcPts val="300"/>
+              </a:spcAft>
+            </a:pPr>
+            <a:r>
+              <a:rPr sz="1100" b="0"/>
+              <a:t>Global (`~/.claude/settings.json`) — minimal — nur Essenzielles: Metriken-Bridge, Session-Speicherung, Session-Auswertung, Kosten-Tracking, Marker</a:t>
+            </a:r>
+          </a:p>
+          <a:p>
+            <a:pPr lvl="1">
+              <a:spcAft>
+                <a:spcPts val="300"/>
+              </a:spcAft>
+            </a:pPr>
+            <a:r>
+              <a:rPr sz="1100" b="0"/>
+              <a:t>Onboarded Projekt (`.claude/settings.json`) — standard — volle Pipeline: quality-gate, console-warn, observe/continuous-learning, governance, context-monitor …</a:t>
+            </a:r>
+          </a:p>
+          <a:p>
+            <a:pPr lvl="1">
+              <a:spcAft>
+                <a:spcPts val="300"/>
+              </a:spcAft>
+            </a:pPr>
+            <a:r>
+              <a:rPr sz="1100" b="0"/>
+              <a:t>(nirgends aktiv) — strict — wie standard + 3 Nag-Erinnerungen (tmux, git-push, commit-quality)</a:t>
             </a:r>
           </a:p>
           <a:p>
@@ -6159,62 +6192,7 @@
             </a:pPr>
             <a:r>
               <a:rPr sz="1200" b="0"/>
-              <a:t>Global aktiv (~/.claude/settings.json):</a:t>
-            </a:r>
-          </a:p>
-          <a:p>
-            <a:pPr>
-              <a:spcAft>
-                <a:spcPts val="300"/>
-              </a:spcAft>
-            </a:pPr>
-            <a:r>
-              <a:rPr sz="1200" b="1"/>
-              <a:t>Hook-Typ · IDs · Zweck</a:t>
-            </a:r>
-          </a:p>
-          <a:p>
-            <a:pPr lvl="1">
-              <a:spcAft>
-                <a:spcPts val="300"/>
-              </a:spcAft>
-            </a:pPr>
-            <a:r>
-              <a:rPr sz="1100" b="0"/>
-              <a:t>PostToolUse — post:quality-gate · post:edit:accumulator · post:edit:console-warn — Quality-Gate nach Edit/Write · Sammel-Formatierung merken · console.log warnen</a:t>
-            </a:r>
-          </a:p>
-          <a:p>
-            <a:pPr lvl="1">
-              <a:spcAft>
-                <a:spcPts val="300"/>
-              </a:spcAft>
-            </a:pPr>
-            <a:r>
-              <a:rPr sz="1100" b="0"/>
-              <a:t>Stop — stop:format-typecheck · stop:check-console-log · stop:session-end — Format+Typecheck · console.log prüfen · Session sichern</a:t>
-            </a:r>
-          </a:p>
-          <a:p>
-            <a:pPr lvl="1">
-              <a:spcAft>
-                <a:spcPts val="300"/>
-              </a:spcAft>
-            </a:pPr>
-            <a:r>
-              <a:rPr sz="1100" b="0"/>
-              <a:t>SessionStart — session:start (Bootstrap) — vorigen Kontext laden, Paketmanager erkennen</a:t>
-            </a:r>
-          </a:p>
-          <a:p>
-            <a:pPr lvl="1">
-              <a:spcAft>
-                <a:spcPts val="300"/>
-              </a:spcAft>
-            </a:pPr>
-            <a:r>
-              <a:rPr sz="1100" b="0"/>
-              <a:t>PreCompact — pre:compact — State sichern vor Kontext-Kompaktierung</a:t>
+              <a:t>Dazu laufen wenige DIRECT-Hooks (Stop: format-typecheck · check-console-log · session-end) überall, no-oppen sich aber ohne relevante Arbeit selbst.</a:t>
             </a:r>
           </a:p>
           <a:p>
@@ -6269,7 +6247,7 @@
             </a:pPr>
             <a:r>
               <a:rPr sz="1200" b="0"/>
-              <a:t>Bewusst abgeschaltet: pre:bash:gateguard-fact-force und pre:edit-write:gateguard-fact-force (GateGuard) via ECC_DISABLED_HOOKS — würden die erste Änderung pro Datei blockieren und Recherche erzwingen (beim normalen Arbeiten störend). Hook-Profil bleibt standard: alle nützlichen Hooks laufen weiter; strict brächte nur drei zusätzliche Nag-Erinnerungen (tmux, git-push, commit-quality).</a:t>
+              <a:t>Bewusst abgeschaltet: GateGuard via ECC_GATEGUARD=off (global) — würde die erste Änderung pro Datei blockieren und Recherche erzwingen (beim normalen Arbeiten störend).</a:t>
             </a:r>
           </a:p>
           <a:p>
@@ -6280,7 +6258,7 @@
             </a:pPr>
             <a:r>
               <a:rPr sz="1200" b="0"/>
-              <a:t>Profil-Steuerung (env in settings.json): ECC_HOOK_PROFILE (minimal/standard/strict) · ECC_DISABLED_HOOKS (gezielt abschalten) · ECC_GOVERNANCE_CAPTURE=1 (Governance-Hooks scharf).</a:t>
+              <a:t>Profil-Steuerung (env in settings.json): ECC_HOOK_PROFILE (minimal/standard/strict) · ECC_GATEGUARD=off (GateGuard aus) · ECC_GOVERNANCE_CAPTURE=1 (Governance-Hooks scharf) · ECC_DISABLED_HOOKS (gezielte ID-Liste, bei dir nicht mehr genutzt). Wirkung erst in frischer Session.</a:t>
             </a:r>
           </a:p>
         </p:txBody>
@@ -6681,7 +6659,7 @@
             </a:pPr>
             <a:r>
               <a:rPr sz="1400" b="0"/>
-              <a:t>• ECC namespace-sicher (rules/ecc/, skills/ecc/) — keine Kollision mit Eigenem.</a:t>
+              <a:t>• ECC namespace-sicher — Core isoliert im Plugin-Cache (ecc@ecc), global verfügbar; kein Projekt-Vendoring (slim/plugin-only) — keine Kollision mit Eigenem.</a:t>
             </a:r>
           </a:p>
           <a:p>
@@ -7084,7 +7062,7 @@
               <a:rPr sz="1400" b="0">
                 <a:latin typeface="Consolas"/>
               </a:rPr>
-              <a:t>cd "/root/projekte/Claude Code BestPractice/ecc"</a:t>
+              <a:t># Plugin-Pfad (Single Source, read-only behandeln):</a:t>
             </a:r>
           </a:p>
           <a:p>
@@ -7097,7 +7075,7 @@
               <a:rPr sz="1400" b="0">
                 <a:latin typeface="Consolas"/>
               </a:rPr>
-              <a:t>node scripts/ecc.js doctor          # Health-Check (claude-home: OK)</a:t>
+              <a:t>ECC=~/.claude/plugins/cache/ecc/ecc/2.0.0-rc.1</a:t>
             </a:r>
           </a:p>
           <a:p>
@@ -7110,7 +7088,7 @@
               <a:rPr sz="1400" b="0">
                 <a:latin typeface="Consolas"/>
               </a:rPr>
-              <a:t>node scripts/ecc.js list-installed  # was ist installiert</a:t>
+              <a:t>node "$ECC/scripts/harness-audit.js"   # Repo-Integritäts-Audit</a:t>
             </a:r>
           </a:p>
           <a:p>
@@ -7123,7 +7101,7 @@
               <a:rPr sz="1400" b="0">
                 <a:latin typeface="Consolas"/>
               </a:rPr>
-              <a:t>node scripts/ecc.js repair          # ECC-Dateien wiederherstellen</a:t>
+              <a:t>node "$ECC/scripts/ecc.js" doctor      # Health-Check</a:t>
             </a:r>
           </a:p>
           <a:p>
@@ -7136,7 +7114,7 @@
               <a:rPr sz="1400" b="0">
                 <a:latin typeface="Consolas"/>
               </a:rPr>
-              <a:t>npx ecc consult "security reviews"  # Advisor: welche Komponenten?</a:t>
+              <a:t># ECC-Update: in ~/.claude/settings.json den Tag anheben …</a:t>
             </a:r>
           </a:p>
           <a:p>
@@ -7149,7 +7127,7 @@
               <a:rPr sz="1400" b="0">
                 <a:latin typeface="Consolas"/>
               </a:rPr>
-              <a:t># Re-Install / Update VPS-weit:</a:t>
+              <a:t>#   extraKnownMarketplaces.ecc.source.ref = "v&lt;neue-version&gt;"</a:t>
             </a:r>
           </a:p>
           <a:p>
@@ -7162,7 +7140,7 @@
               <a:rPr sz="1400" b="0">
                 <a:latin typeface="Consolas"/>
               </a:rPr>
-              <a:t>cd "/root/projekte/Claude Code BestPractice" &amp;&amp; ./install-vps.sh</a:t>
+              <a:t># … dann Claude Code neu starten (Plugin wird neu gecacht).</a:t>
             </a:r>
           </a:p>
           <a:p>
@@ -7173,7 +7151,7 @@
             </a:pPr>
             <a:r>
               <a:rPr sz="1600" b="0"/>
-              <a:t>Slash-Einstieg: /ecc-guide (Onboarding), /harness-audit (Config-Scorecard), /cost-report, /skill-health, /projects.</a:t>
+              <a:t>Slash-Einstieg: /ecc-guide (Onboarding), /harness-audit (Config-Scorecard), /cost-report, /skill-health, /projects. ⚠️ Plugin-/Settings-Änderungen greifen erst nach Neustart von Claude Code (/clear reicht nicht).</a:t>
             </a:r>
           </a:p>
         </p:txBody>
@@ -7302,7 +7280,7 @@
             </a:pPr>
             <a:r>
               <a:rPr sz="1200" b="0"/>
-              <a:t>Der BestPractice-Wrapper koppelt persistenten Projekt-State an ECCs Loop und stellt /mega-plan als Planungs-Vorstufe bereit — rein additiv. Der ECC-Core (ecc/) bleibt unverändert.</a:t>
+              <a:t>Der BestPractice-Wrapper koppelt persistenten Projekt-State an ECCs Loop und stellt /mega-plan als Planungs-Vorstufe bereit — rein additiv. Der ECC-Core (das globale Plugin) bleibt unverändert.</a:t>
             </a:r>
           </a:p>
           <a:p>
@@ -7694,7 +7672,7 @@
             </a:pPr>
             <a:r>
               <a:rPr sz="1200" b="0"/>
-              <a:t>ECC-Core unberührt: Alles liegt in bestpractice-extras/. git diff zeigt keine Änderung unter ecc/. Tiefe Doku: docs/MEGA-WORKFLOW.de.md.</a:t>
+              <a:t>ECC-Core unberührt: Alles liegt in bestpractice-extras/; am Plugin unter ~/.claude/plugins/cache/ecc/ wird nie gepatcht. Tiefe Doku: docs/MEGA-WORKFLOW.de.md.</a:t>
             </a:r>
           </a:p>
         </p:txBody>
@@ -7789,7 +7767,7 @@
                   <a:srgbClr val="FFFFFF"/>
                 </a:solidFill>
               </a:rPr>
-              <a:t>20 · Aktivierungs-Status &amp; behobene Bugs (Stand 2026-06-05)</a:t>
+              <a:t>20 · Aktivierungs-Status (Stand 2026-06-10 — Plugin-only-Migration)</a:t>
             </a:r>
           </a:p>
         </p:txBody>
@@ -7822,96 +7800,85 @@
               </a:spcAft>
             </a:pPr>
             <a:r>
-              <a:rPr sz="1400" b="0"/>
-              <a:t>Das BestPractice-Repo selbst ist onboardet und die Schicht-2-Mechanik ist scharf:</a:t>
-            </a:r>
-          </a:p>
-          <a:p>
-            <a:pPr>
-              <a:spcAft>
-                <a:spcPts val="300"/>
-              </a:spcAft>
-            </a:pPr>
-            <a:r>
-              <a:rPr sz="1400" b="0"/>
-              <a:t>• State-Sync aktiv (Variante A, projekt-lokal): .claude/settings.json enthält additiv SessionStart→pre, Stop→post, PreCompact→post (Aufruf bestpractice-extras/scripts/state-sync/state-sync.js). Der ecc/-Schreibguard bleibt unberührt. state/{context,decisions,progress,tasks}.md ist befüllt, WORKING-CONTEXT.md wird beim Session-Start aus state/ gespiegelt.</a:t>
-            </a:r>
-          </a:p>
-          <a:p>
-            <a:pPr>
-              <a:spcAft>
-                <a:spcPts val="300"/>
-              </a:spcAft>
-            </a:pPr>
-            <a:r>
-              <a:rPr sz="1400" b="0"/>
-              <a:t>• Globale ecc-onboard.md-Drift behoben: war veraltet (6,3 K ohne Schritt 4b/4c); jetzt = Repo-Version (13 K mit State-Sync-Verdrahtung + consumer-scaffold).</a:t>
-            </a:r>
-          </a:p>
-          <a:p>
-            <a:pPr>
-              <a:spcAft>
-                <a:spcPts val="300"/>
-              </a:spcAft>
-            </a:pPr>
-            <a:r>
-              <a:rPr sz="1400" b="0"/>
-              <a:t>• Global gelayerte Extras erweitert: rpi-Advisors (~/.claude/agents/), attribution-policy.md (~/.claude/rules/ecc-extras/), Dynamic-Context-Profile contexts/{dev,review}.md (~/.claude/contexts/). install-vps.sh deployt das künftig automatisch.</a:t>
-            </a:r>
-          </a:p>
-          <a:p>
-            <a:pPr>
-              <a:spcAft>
-                <a:spcPts val="300"/>
-              </a:spcAft>
-            </a:pPr>
-            <a:r>
-              <a:rPr sz="1400" b="0"/>
-              <a:t>• mgrep + LSP verankert: mgrep als Schicht-2-Tool (MXBAI_API_KEY, index.sh); LSP-Plugins typescript-lsp + pyright-lsp user-scoped installiert.</a:t>
-            </a:r>
-          </a:p>
-          <a:p>
-            <a:pPr>
-              <a:spcAft>
-                <a:spcPts val="300"/>
-              </a:spcAft>
-            </a:pPr>
-            <a:r>
-              <a:rPr sz="1400" b="0"/>
-              <a:t>• Unberührt: ECC-Core (git status -- ecc/ leer), RTK-Hook (PreToolUse:Bash global), globale ECC-Lifecycle-Hooks.</a:t>
-            </a:r>
-          </a:p>
-          <a:p>
-            <a:pPr>
-              <a:spcAft>
-                <a:spcPts val="300"/>
-              </a:spcAft>
-            </a:pPr>
-            <a:r>
-              <a:rPr sz="1400" b="0"/>
-              <a:t>Behobene Bugs:</a:t>
-            </a:r>
-          </a:p>
-          <a:p>
-            <a:pPr>
-              <a:spcAft>
-                <a:spcPts val="300"/>
-              </a:spcAft>
-            </a:pPr>
-            <a:r>
-              <a:rPr sz="1400" b="0"/>
-              <a:t>• /ecc-onboard install-plan.js vs install-apply.js (behoben 2026-06-03): install-plan.js übergab kein projectRoot → Install landete im ECC-Repo statt im Zielprojekt. Fix: für Dry-Run immer node "$ECC_REPO/scripts/install-apply.js" --target claude-project --profile &lt;profil&gt; --dry-run aus dem Zielprojekt-Root.</a:t>
-            </a:r>
-          </a:p>
-          <a:p>
-            <a:pPr>
-              <a:spcAft>
-                <a:spcPts val="300"/>
-              </a:spcAft>
-            </a:pPr>
-            <a:r>
-              <a:rPr sz="1400" b="0"/>
-              <a:t>• Attribution-Policy (Schicht-2-Override): Co-Authorship ist für dieses Setup AKTIV (Commits enden mit Co-Authored-By:); der Upstream-Hinweis „Attribution disabled globally" im vendored Core gilt hier bewusst nicht.</a:t>
+              <a:rPr sz="1600" b="0"/>
+              <a:t>Die Migration auf Plugin-only ist abgeschlossen (Commits d99f3d0 + 8293011):</a:t>
+            </a:r>
+          </a:p>
+          <a:p>
+            <a:pPr>
+              <a:spcAft>
+                <a:spcPts val="300"/>
+              </a:spcAft>
+            </a:pPr>
+            <a:r>
+              <a:rPr sz="1600" b="0"/>
+              <a:t>• ECC-Core = globales Plugin ecc@ecc 2.0.0-rc.1, gepinnt auf GitHub affaan-m/ECC Tag v2.0.0-rc.1 (extraKnownMarketplaces in ~/.claude/settings.json). Vendored ecc/ im Repo und der 213-MB-Klon /root/projekte/ECC sind gelöscht.</a:t>
+            </a:r>
+          </a:p>
+          <a:p>
+            <a:pPr>
+              <a:spcAft>
+                <a:spcPts val="300"/>
+              </a:spcAft>
+            </a:pPr>
+            <a:r>
+              <a:rPr sz="1600" b="0"/>
+              <a:t>• ECC-Duplikate im Home entfernt: globale Rules- (117 Dateien, verursachten Auto-Compact), Hooks- und Skills-Kopien sind weg — das Plugin liefert alles. Geblieben: 3 Schicht-2-Command-Symlinks (start, mega-plan, ecc-onboard), skills/learned, skills/system-architektur, rules/ecc-extras/.</a:t>
+            </a:r>
+          </a:p>
+          <a:p>
+            <a:pPr>
+              <a:spcAft>
+                <a:spcPts val="300"/>
+              </a:spcAft>
+            </a:pPr>
+            <a:r>
+              <a:rPr sz="1600" b="0"/>
+              <a:t>• Abgelöst (Plugins auf false): claude-mem → memory-MCP + Instincts + /save-session · superpowers → ECC-Workflows · context7@official + feature-dev → ECC-Pendants. ⚠️ Greift erst nach Neustart von Claude Code.</a:t>
+            </a:r>
+          </a:p>
+          <a:p>
+            <a:pPr>
+              <a:spcAft>
+                <a:spcPts val="300"/>
+              </a:spcAft>
+            </a:pPr>
+            <a:r>
+              <a:rPr sz="1600" b="0"/>
+              <a:t>• Hook-Scope: global minimal + ECC_GATEGUARD=off; onboarded Projekte lokal standard (BestPractice, Werkstattauftraege_codex, Grow3_Automatisierung, Test-ECC, Verladelisten_Hafen). Eigenbau-hooks.py aus Werkstatt/WMS_Test entfernt.</a:t>
+            </a:r>
+          </a:p>
+          <a:p>
+            <a:pPr>
+              <a:spcAft>
+                <a:spcPts val="300"/>
+              </a:spcAft>
+            </a:pPr>
+            <a:r>
+              <a:rPr sz="1600" b="0"/>
+              <a:t>• State-Sync aktiv (GLOBAL): ~/.claude/settings.json → SessionStart→pre, Stop/PreCompact→post über ~/.claude/state-sync/ (Symlink→Repo-Engine), guard-gated. Onboarded Projekte brauchen keine eigenen state-sync-Hooks.</a:t>
+            </a:r>
+          </a:p>
+          <a:p>
+            <a:pPr>
+              <a:spcAft>
+                <a:spcPts val="300"/>
+              </a:spcAft>
+            </a:pPr>
+            <a:r>
+              <a:rPr sz="1600" b="0"/>
+              <a:t>• Backup: kompletter Vor-Migrations-Stand unter /root/harness-backup-20260610/ (inkl. geretteter Eigenarbeit ecc-clone-eigenes/).</a:t>
+            </a:r>
+          </a:p>
+          <a:p>
+            <a:pPr>
+              <a:spcAft>
+                <a:spcPts val="300"/>
+              </a:spcAft>
+            </a:pPr>
+            <a:r>
+              <a:rPr sz="1600" b="0"/>
+              <a:t>• Unberührt: RTK-Hook (PreToolUse:Bash global) · Attribution-Policy (Schicht-2-Override): Co-Authorship AKTIV, der Upstream-Hinweis „Attribution disabled globally" gilt hier bewusst nicht.</a:t>
             </a:r>
           </a:p>
         </p:txBody>
@@ -8040,7 +8007,7 @@
             </a:pPr>
             <a:r>
               <a:rPr sz="1200" b="0"/>
-              <a:t>Original-Guides von @affaanmustafa (als X-Threads veröffentlicht; lokal im Repo unter ecc/):</a:t>
+              <a:t>Original-Guides von @affaanmustafa (als X-Threads veröffentlicht; lokal im Plugin-Cache ~/.claude/plugins/cache/ecc/ecc/2.0.0-rc.1/):</a:t>
             </a:r>
           </a:p>
           <a:p>
@@ -8051,7 +8018,7 @@
             </a:pPr>
             <a:r>
               <a:rPr sz="1200" b="0"/>
-              <a:t>• Shortform-Guide: https://x.com/affaanmustafa/status/2012378465664745795 (ecc/the-shortform-guide.md) — Setup &amp; Philosophie</a:t>
+              <a:t>• Shortform-Guide: https://x.com/affaanmustafa/status/2012378465664745795 (the-shortform-guide.md) — Setup &amp; Philosophie</a:t>
             </a:r>
           </a:p>
           <a:p>
@@ -8062,7 +8029,7 @@
             </a:pPr>
             <a:r>
               <a:rPr sz="1200" b="0"/>
-              <a:t>• Longform-Guide: https://x.com/affaanmustafa/status/2014040193557471352 (ecc/the-longform-guide.md) — Token, Memory, Evals, Parallelisierung</a:t>
+              <a:t>• Longform-Guide: https://x.com/affaanmustafa/status/2014040193557471352 (the-longform-guide.md) — Token, Memory, Evals, Parallelisierung</a:t>
             </a:r>
           </a:p>
           <a:p>
@@ -8073,7 +8040,7 @@
             </a:pPr>
             <a:r>
               <a:rPr sz="1200" b="0"/>
-              <a:t>• Security-Guide: https://x.com/affaanmustafa/status/2033263813387223421 (ecc/the-security-guide.md) — Agent-Security, Pflichtlektüre</a:t>
+              <a:t>• Security-Guide: https://x.com/affaanmustafa/status/2033263813387223421 (the-security-guide.md) — Agent-Security, Pflichtlektüre</a:t>
             </a:r>
           </a:p>
           <a:p>
@@ -8290,7 +8257,7 @@
             </a:pPr>
             <a:r>
               <a:rPr sz="1200" b="0"/>
-              <a:t>ECC ist GLOBAL nach ~/.claude installiert und damit in JEDEM Projekt auf der VPS aktiv (WMS, Jarvis, n8n, Werkstatt …). Die Installation ist bewusst additiv und namespace-sicher:</a:t>
+              <a:t>ECC läuft als globales Plugin und ist damit in JEDEM Projekt auf der VPS verfügbar (WMS, Jarvis, n8n, Werkstatt …). Das Setup ist bewusst schlank und reproduzierbar:</a:t>
             </a:r>
           </a:p>
           <a:p>
@@ -8301,7 +8268,7 @@
             </a:pPr>
             <a:r>
               <a:rPr sz="1200" b="0"/>
-              <a:t>• Namespace-sicher: ECC liegt unter rules/ecc/ und skills/ecc/ — keine Kollision mit Eigenem.</a:t>
+              <a:t>• Plugin-only: Single Source ist ~/.claude/plugins/cache/ecc/ecc/2.0.0-rc.1/ — keine Kopien mehr unter ~/.claude/{rules,hooks,skills,commands} und keine vendored ecc/ im Repo. Update = extraKnownMarketplaces.ecc.source.ref in ~/.claude/settings.json auf neuen Tag setzen.</a:t>
             </a:r>
           </a:p>
           <a:p>
@@ -8323,7 +8290,7 @@
             </a:pPr>
             <a:r>
               <a:rPr sz="1200" b="0"/>
-              <a:t>• Startup-Config additiv: Der Installer lässt settings.json/CLAUDE.md unberührt. Bewusste Aufräum-Schritte (feature-dev-Plugin deaktiviert, context-mode entfernt) wurden separat mit Backup vorgenommen.</a:t>
+              <a:t>• Hook-Zähmung per Profil: global ECC_HOOK_PROFILE=minimal (Nicht-ECC-Projekte ruhig), projekt-lokal standard in onboardeten Projekten (volle Pipeline). Details §14.</a:t>
             </a:r>
           </a:p>
           <a:p>
@@ -8334,7 +8301,7 @@
             </a:pPr>
             <a:r>
               <a:rPr sz="1200" b="0"/>
-              <a:t>• Reproduzierbar: Quelle ist das Repo; Re-Install via ./install-vps.sh (idempotent, mit Backup).</a:t>
+              <a:t>• Backup: kompletter Vor-Migrations-Stand unter /root/harness-backup-20260610/.</a:t>
             </a:r>
           </a:p>
           <a:p>
@@ -8345,7 +8312,7 @@
             </a:pPr>
             <a:r>
               <a:rPr sz="1200" b="0"/>
-              <a:t>Koexistenz mit deinem bestehenden Setup:</a:t>
+              <a:t>Abgelöste Plugins (in enabledPlugins auf false — Änderung greift erst nach Claude-Code-Neustart):</a:t>
             </a:r>
           </a:p>
           <a:p>
@@ -8356,7 +8323,7 @@
             </a:pPr>
             <a:r>
               <a:rPr sz="1200" b="1"/>
-              <a:t>Dein Tool · ECC-Pendant · Empfehlung</a:t>
+              <a:t>Plugin (aus) · ECC-Pendant (führend)</a:t>
             </a:r>
           </a:p>
           <a:p>
@@ -8367,7 +8334,7 @@
             </a:pPr>
             <a:r>
               <a:rPr sz="1100" b="0"/>
-              <a:t>superpowers — tdd-workflow, verification-loop … — Beides nutzbar; bei Doppelung ECC bevorzugen</a:t>
+              <a:t>superpowers — tdd-workflow, verification-loop, dispatching über ECC-Agents</a:t>
             </a:r>
           </a:p>
           <a:p>
@@ -8378,7 +8345,7 @@
             </a:pPr>
             <a:r>
               <a:rPr sz="1100" b="0"/>
-              <a:t>claude-mem — /save-session, continuous-learning-v2 — primäre Memory-Quelle; injiziert Kontext automatisch</a:t>
+              <a:t>claude-mem — memory-MCP (Wissensgraph) + Instincts + /save-session</a:t>
             </a:r>
           </a:p>
           <a:p>
@@ -8389,7 +8356,7 @@
             </a:pPr>
             <a:r>
               <a:rPr sz="1100" b="0"/>
-              <a:t>RTK — Token-Ökonomie (§10) — Ergänzen sich: RTK auf Bash-, ECC auf Workflow-Ebene</a:t>
+              <a:t>context7@official — ECC bringt eigenes context7-MCP mit</a:t>
             </a:r>
           </a:p>
           <a:p>
@@ -8400,7 +8367,7 @@
             </a:pPr>
             <a:r>
               <a:rPr sz="1100" b="0"/>
-              <a:t>codex / superpowers — diverse Skills/Agents — eigenständiger Mehrwert; bleiben aktiv</a:t>
+              <a:t>feature-dev — /feature-dev (ECC-Command)</a:t>
             </a:r>
           </a:p>
           <a:p>
@@ -8411,7 +8378,7 @@
             </a:pPr>
             <a:r>
               <a:rPr sz="1200" b="0"/>
-              <a:t>Aufgeräumt: feature-dev existierte 3-fach — die ECC-Version ist kanonisch, das gleichnamige Plugin wurde deaktiviert. RPI als Plugin wurde entfernt (durch die schlanken Schicht-2-RPI-Berater ersetzt). Bei Namens-Zweifeln eindeutige ECC-Commands nutzen (/harness-audit, /ecc-guide, /ecc-onboard, /instinct-status).</a:t>
+              <a:t>Weiter aktiv neben ECC: codex, mgrep, LSP-Plugins, frontend-design, skill-creator u. a. — eigenständiger Mehrwert ohne Doppelung. Bei Namens-Zweifeln eindeutige ECC-Commands nutzen (/harness-audit, /ecc-guide, /ecc-onboard, /instinct-status).</a:t>
             </a:r>
           </a:p>
         </p:txBody>
@@ -8540,7 +8507,7 @@
             </a:pPr>
             <a:r>
               <a:rPr sz="1400" b="1"/>
-              <a:t>Baustein · Was es ist · Wo (global) · Lebensdauer</a:t>
+              <a:t>Baustein · Was es ist · Wo · Lebensdauer</a:t>
             </a:r>
           </a:p>
           <a:p>
@@ -8551,7 +8518,7 @@
             </a:pPr>
             <a:r>
               <a:rPr sz="1300" b="0"/>
-              <a:t>Skills — Durable Kern: wiederverwendbare Workflow-Bündel, laden on-demand — ~/.claude/skills/ecc/ — langlebig</a:t>
+              <a:t>Skills — Durable Kern: wiederverwendbare Workflow-Bündel, laden on-demand — Plugin `skills/` (alle 249) — langlebig</a:t>
             </a:r>
           </a:p>
           <a:p>
@@ -8562,7 +8529,7 @@
             </a:pPr>
             <a:r>
               <a:rPr sz="1300" b="0"/>
-              <a:t>Commands — Slash-Einstiegspunkte (/plan, /code-review …) — ~/.claude/commands/ — Komfort-Schicht</a:t>
+              <a:t>Commands — Slash-Einstiegspunkte (/plan, /code-review …) — Plugin `commands/` (+ 3 Schicht-2: /start, /mega-plan, /ecc-onboard) — Komfort-Schicht</a:t>
             </a:r>
           </a:p>
           <a:p>
@@ -8573,7 +8540,7 @@
             </a:pPr>
             <a:r>
               <a:rPr sz="1300" b="0"/>
-              <a:t>Subagents — Delegierbare Spezialisten mit eigenem Tool-Scope — ~/.claude/agents/ — pro Aufgabe</a:t>
+              <a:t>Subagents — Delegierbare Spezialisten mit eigenem Tool-Scope + festem Modell — Plugin `agents/` (+ RPI-Berater in bestpractice-extras/) — pro Aufgabe</a:t>
             </a:r>
           </a:p>
           <a:p>
@@ -8584,7 +8551,7 @@
             </a:pPr>
             <a:r>
               <a:rPr sz="1300" b="0"/>
-              <a:t>Hooks — Trigger-Automatik an Lifecycle-Events (s. §14) — ~/.claude/hooks/ — event-gebunden</a:t>
+              <a:t>Hooks — Trigger-Automatik an Lifecycle-Events (s. §14) — Plugin `hooks/hooks.json`, gesteuert per ECC_HOOK_PROFILE — event-gebunden</a:t>
             </a:r>
           </a:p>
           <a:p>
@@ -8595,7 +8562,7 @@
             </a:pPr>
             <a:r>
               <a:rPr sz="1300" b="0"/>
-              <a:t>Rules — „Immer befolgen"-Leitlinien je Sprache — ~/.claude/rules/ecc/ — dauerhaft</a:t>
+              <a:t>Rules — „Immer befolgen"-Leitlinien je Sprache — **global** im Plugin (`ecc@ecc`) — kein Projekt-Vendoring mehr — dauerhaft</a:t>
             </a:r>
           </a:p>
           <a:p>
@@ -8606,7 +8573,7 @@
             </a:pPr>
             <a:r>
               <a:rPr sz="1300" b="0"/>
-              <a:t>MCP — Prompt-getriebene Wrapper um externe Dienste — .mcp.json / global — pro Session</a:t>
+              <a:t>MCP — Externe Dienste als Tools (memory, context7, github, exa, playwright, sequential-thinking) — Plugin `.mcp.json` — pro Session</a:t>
             </a:r>
           </a:p>
           <a:p>
@@ -8617,7 +8584,18 @@
             </a:pPr>
             <a:r>
               <a:rPr sz="1300" b="0"/>
-              <a:t>Instincts — Gelernte Muster aus deinen Sessions — homunculus/instincts/ — wächst mit dir</a:t>
+              <a:t>Instincts — Gelernte Muster aus deinen Sessions — ~/.claude (continuous-learning), /instinct-status — wächst mit dir</a:t>
+            </a:r>
+          </a:p>
+          <a:p>
+            <a:pPr>
+              <a:spcAft>
+                <a:spcPts val="300"/>
+              </a:spcAft>
+            </a:pPr>
+            <a:r>
+              <a:rPr sz="1400" b="0"/>
+              <a:t>(Plugin-Pfad jeweils: ~/.claude/plugins/cache/ecc/ecc/2.0.0-rc.1/.)</a:t>
             </a:r>
           </a:p>
           <a:p>
@@ -8889,7 +8867,7 @@
             </a:pPr>
             <a:r>
               <a:rPr sz="1200" b="0"/>
-              <a:t>Mehr verfügbar: Mehr (249 Skills) via ./install-vps.sh --profile full. claude-mem (mem-search, smart-explore) + superpowers koexistieren.</a:t>
+              <a:t>Alle 249 Skills liefert das Plugin direkt — kein Install-Profil mehr nötig. claude-mem und superpowers sind deaktiviert; ihre Aufgaben übernehmen memory-MCP/Instincts bzw. die ECC-Workflows (tdd-workflow, verification-loop).</a:t>
             </a:r>
           </a:p>
         </p:txBody>
@@ -9040,7 +9018,7 @@
             </a:pPr>
             <a:r>
               <a:rPr sz="1300" b="0"/>
-              <a:t>1 · RESEARCH — Explore-Agent / claude-mem — research.md</a:t>
+              <a:t>1 · RESEARCH — Explore-Agent / memory-MCP (search_nodes) — research.md</a:t>
             </a:r>
           </a:p>
           <a:p>
@@ -9279,7 +9257,7 @@
             </a:pPr>
             <a:r>
               <a:rPr sz="1200" b="0"/>
-              <a:t>Ein Command, ein OK: erkennt den Stack, installiert ECC project-level und legt persistente Projekt-Dateien an, die Claude künftig zuerst liest.</a:t>
+              <a:t>Ein Command, ein OK: schlank (plugin-only). ECC-Core ist global — ins Projekt kommt nur der minimale projektlokale Kern. Ein deterministisches Script (onboard.js) erledigt die Mechanik, eine maschinelle Abnahme (onboard-verify.js) belegt „fertig". Kein Vendoring (.claude/rules/ecc etc.), funktioniert auch in Fremd-Repos.</a:t>
             </a:r>
           </a:p>
           <a:p>
@@ -9301,7 +9279,7 @@
             </a:pPr>
             <a:r>
               <a:rPr sz="1100" b="0"/>
-              <a:t>1 · Detect — Stack aus package.json / go.mod / pyproject.toml … erkennen — Profil + Sprach-Packs</a:t>
+              <a:t>1 · Dry-Run — `onboard.js --project &lt;dir&gt;` — Preflight + De-Cruft-Plan + Slim-Scaffold-Plan, schreibt nichts</a:t>
             </a:r>
           </a:p>
           <a:p>
@@ -9312,7 +9290,7 @@
             </a:pPr>
             <a:r>
               <a:rPr sz="1100" b="0"/>
-              <a:t>2 · Dry-Run — install-apply --target claude-project --dry-run — Plan ohne Schreiben</a:t>
+              <a:t>2 · Bestätigung — 1× OK des Users — Freigabe</a:t>
             </a:r>
           </a:p>
           <a:p>
@@ -9323,7 +9301,7 @@
             </a:pPr>
             <a:r>
               <a:rPr sz="1100" b="0"/>
-              <a:t>3 · Bestätigung — 1× OK des Users — Freigabe</a:t>
+              <a:t>3 · Apply — `onboard.js --apply` — De-Cruft (Altlasten → `.harness-backup/`) + Slim-Scaffold</a:t>
             </a:r>
           </a:p>
           <a:p>
@@ -9334,7 +9312,7 @@
             </a:pPr>
             <a:r>
               <a:rPr sz="1100" b="0"/>
-              <a:t>4 · Install — install-apply --target claude-project — .claude/rules/ecc/ + skills/ecc/</a:t>
+              <a:t>4 · Slim-Kern — env-Block + `state/` + Sentinel + `.gitignore` + consumer-Artefakte + initialer PRE — `.claude/settings.json`, `state/*`, `WORKING-CONTEXT.md`</a:t>
             </a:r>
           </a:p>
           <a:p>
@@ -9345,7 +9323,7 @@
             </a:pPr>
             <a:r>
               <a:rPr sz="1100" b="0"/>
-              <a:t>5 · Kontext — Templates mit echten Werten füllen — PROJECT_RULES.md + state/*</a:t>
+              <a:t>5 · Verfeinern — Templates mit echten Werten füllen + `onboard-verify` — PROJECT_RULES.md + CLAUDE.md, alle Pflicht-Checks grün</a:t>
             </a:r>
           </a:p>
           <a:p>
@@ -9573,7 +9551,7 @@
             </a:pPr>
             <a:r>
               <a:rPr sz="1400" b="0"/>
-              <a:t>Wann neu bauen? Codemaps sind ein Snapshot — sie aktualisieren sich nicht von selbst. Nach größeren Architektur-Änderungen /update-codemaps erneut laufen lassen. Erstes Mal in einem fremden Repo: code-tour-Skill bzw. claude-mem smart-explore/learn-codebase erzeugen Touren/Struktur.</a:t>
+              <a:t>Wann neu bauen? Codemaps sind ein Snapshot — sie aktualisieren sich nicht von selbst. Nach größeren Architektur-Änderungen /update-codemaps erneut laufen lassen. Erstes Mal in einem fremden Repo: code-tour- bzw. codebase-onboarding-Skill erzeugen Touren/Struktur.</a:t>
             </a:r>
           </a:p>
           <a:p>
@@ -9617,7 +9595,7 @@
             </a:pPr>
             <a:r>
               <a:rPr sz="1400" b="0"/>
-              <a:t>• claude-mem ergänzt: Injiziert relevanten Kontext aus früheren Sessions ab der 2. Session automatisch. /mem-search für gezielte Treffer („schon mal gelöst?").</a:t>
+              <a:t>• Memory ergänzt: Der ECC-SessionStart-Hook lädt Session-Kontext; in onboardeten Projekten spiegelt State-Sync state/ nach WORKING-CONTEXT.md. Gezielt nachschlagen („schon mal gelöst?"): memory-MCP search_nodes + /instinct-status.</a:t>
             </a:r>
           </a:p>
           <a:p>
@@ -9818,7 +9796,7 @@
               <a:rPr sz="1000" b="0">
                 <a:latin typeface="Consolas"/>
               </a:rPr>
-              <a:t>/ecc-onboard           # Stack-Frage → 1x OK → .claude/rules+skills, PROJECT_RULES.md, state/</a:t>
+              <a:t>/ecc-onboard           # Dry-Run → 1x OK → De-Cruft + slim Scaffold (env, state/, PROJECT_RULES.md) → Abnahme</a:t>
             </a:r>
           </a:p>
           <a:p>

</xml_diff>